<commit_message>
User Address- Working with create page
</commit_message>
<xml_diff>
--- a/.lessons/66 Frontend User Multi address/2 User Address- Working with create page/1.pptx
+++ b/.lessons/66 Frontend User Multi address/2 User Address- Working with create page/1.pptx
@@ -7,9 +7,31 @@
   <p:sldIdLst>
     <p:sldId id="415" r:id="rId2"/>
     <p:sldId id="416" r:id="rId3"/>
-    <p:sldId id="417" r:id="rId4"/>
-    <p:sldId id="418" r:id="rId5"/>
-    <p:sldId id="419" r:id="rId6"/>
+    <p:sldId id="420" r:id="rId4"/>
+    <p:sldId id="421" r:id="rId5"/>
+    <p:sldId id="417" r:id="rId6"/>
+    <p:sldId id="418" r:id="rId7"/>
+    <p:sldId id="422" r:id="rId8"/>
+    <p:sldId id="425" r:id="rId9"/>
+    <p:sldId id="426" r:id="rId10"/>
+    <p:sldId id="423" r:id="rId11"/>
+    <p:sldId id="424" r:id="rId12"/>
+    <p:sldId id="428" r:id="rId13"/>
+    <p:sldId id="427" r:id="rId14"/>
+    <p:sldId id="429" r:id="rId15"/>
+    <p:sldId id="431" r:id="rId16"/>
+    <p:sldId id="430" r:id="rId17"/>
+    <p:sldId id="432" r:id="rId18"/>
+    <p:sldId id="433" r:id="rId19"/>
+    <p:sldId id="434" r:id="rId20"/>
+    <p:sldId id="436" r:id="rId21"/>
+    <p:sldId id="435" r:id="rId22"/>
+    <p:sldId id="437" r:id="rId23"/>
+    <p:sldId id="438" r:id="rId24"/>
+    <p:sldId id="439" r:id="rId25"/>
+    <p:sldId id="419" r:id="rId26"/>
+    <p:sldId id="440" r:id="rId27"/>
+    <p:sldId id="441" r:id="rId28"/>
   </p:sldIdLst>
   <p:sldSz cx="12192000" cy="6858000"/>
   <p:notesSz cx="6858000" cy="9144000"/>
@@ -263,7 +285,7 @@
           <a:p>
             <a:fld id="{3E102D2E-813C-461C-9963-687A650C48C0}" type="datetimeFigureOut">
               <a:rPr lang="en-US" smtClean="0"/>
-              <a:t>12/24/2025</a:t>
+              <a:t>12/31/2025</a:t>
             </a:fld>
             <a:endParaRPr lang="en-US"/>
           </a:p>
@@ -461,7 +483,7 @@
           <a:p>
             <a:fld id="{3E102D2E-813C-461C-9963-687A650C48C0}" type="datetimeFigureOut">
               <a:rPr lang="en-US" smtClean="0"/>
-              <a:t>12/24/2025</a:t>
+              <a:t>12/31/2025</a:t>
             </a:fld>
             <a:endParaRPr lang="en-US"/>
           </a:p>
@@ -669,7 +691,7 @@
           <a:p>
             <a:fld id="{3E102D2E-813C-461C-9963-687A650C48C0}" type="datetimeFigureOut">
               <a:rPr lang="en-US" smtClean="0"/>
-              <a:t>12/24/2025</a:t>
+              <a:t>12/31/2025</a:t>
             </a:fld>
             <a:endParaRPr lang="en-US"/>
           </a:p>
@@ -867,7 +889,7 @@
           <a:p>
             <a:fld id="{3E102D2E-813C-461C-9963-687A650C48C0}" type="datetimeFigureOut">
               <a:rPr lang="en-US" smtClean="0"/>
-              <a:t>12/24/2025</a:t>
+              <a:t>12/31/2025</a:t>
             </a:fld>
             <a:endParaRPr lang="en-US"/>
           </a:p>
@@ -1142,7 +1164,7 @@
           <a:p>
             <a:fld id="{3E102D2E-813C-461C-9963-687A650C48C0}" type="datetimeFigureOut">
               <a:rPr lang="en-US" smtClean="0"/>
-              <a:t>12/24/2025</a:t>
+              <a:t>12/31/2025</a:t>
             </a:fld>
             <a:endParaRPr lang="en-US"/>
           </a:p>
@@ -1407,7 +1429,7 @@
           <a:p>
             <a:fld id="{3E102D2E-813C-461C-9963-687A650C48C0}" type="datetimeFigureOut">
               <a:rPr lang="en-US" smtClean="0"/>
-              <a:t>12/24/2025</a:t>
+              <a:t>12/31/2025</a:t>
             </a:fld>
             <a:endParaRPr lang="en-US"/>
           </a:p>
@@ -1819,7 +1841,7 @@
           <a:p>
             <a:fld id="{3E102D2E-813C-461C-9963-687A650C48C0}" type="datetimeFigureOut">
               <a:rPr lang="en-US" smtClean="0"/>
-              <a:t>12/24/2025</a:t>
+              <a:t>12/31/2025</a:t>
             </a:fld>
             <a:endParaRPr lang="en-US"/>
           </a:p>
@@ -1960,7 +1982,7 @@
           <a:p>
             <a:fld id="{3E102D2E-813C-461C-9963-687A650C48C0}" type="datetimeFigureOut">
               <a:rPr lang="en-US" smtClean="0"/>
-              <a:t>12/24/2025</a:t>
+              <a:t>12/31/2025</a:t>
             </a:fld>
             <a:endParaRPr lang="en-US"/>
           </a:p>
@@ -2073,7 +2095,7 @@
           <a:p>
             <a:fld id="{3E102D2E-813C-461C-9963-687A650C48C0}" type="datetimeFigureOut">
               <a:rPr lang="en-US" smtClean="0"/>
-              <a:t>12/24/2025</a:t>
+              <a:t>12/31/2025</a:t>
             </a:fld>
             <a:endParaRPr lang="en-US"/>
           </a:p>
@@ -2384,7 +2406,7 @@
           <a:p>
             <a:fld id="{3E102D2E-813C-461C-9963-687A650C48C0}" type="datetimeFigureOut">
               <a:rPr lang="en-US" smtClean="0"/>
-              <a:t>12/24/2025</a:t>
+              <a:t>12/31/2025</a:t>
             </a:fld>
             <a:endParaRPr lang="en-US"/>
           </a:p>
@@ -2672,7 +2694,7 @@
           <a:p>
             <a:fld id="{3E102D2E-813C-461C-9963-687A650C48C0}" type="datetimeFigureOut">
               <a:rPr lang="en-US" smtClean="0"/>
-              <a:t>12/24/2025</a:t>
+              <a:t>12/31/2025</a:t>
             </a:fld>
             <a:endParaRPr lang="en-US"/>
           </a:p>
@@ -2913,7 +2935,7 @@
           <a:p>
             <a:fld id="{3E102D2E-813C-461C-9963-687A650C48C0}" type="datetimeFigureOut">
               <a:rPr lang="en-US" smtClean="0"/>
-              <a:t>12/24/2025</a:t>
+              <a:t>12/31/2025</a:t>
             </a:fld>
             <a:endParaRPr lang="en-US"/>
           </a:p>
@@ -3386,10 +3408,1320 @@
           </a:p>
         </p:txBody>
       </p:sp>
+      <p:pic>
+        <p:nvPicPr>
+          <p:cNvPr id="4" name="Picture 3">
+            <a:extLst>
+              <a:ext uri="{FF2B5EF4-FFF2-40B4-BE49-F238E27FC236}">
+                <a16:creationId xmlns:a16="http://schemas.microsoft.com/office/drawing/2014/main" id="{2E235039-3E0C-5B2D-4E03-ACF15A2AADD2}"/>
+              </a:ext>
+            </a:extLst>
+          </p:cNvPr>
+          <p:cNvPicPr>
+            <a:picLocks noChangeAspect="1"/>
+          </p:cNvPicPr>
+          <p:nvPr/>
+        </p:nvPicPr>
+        <p:blipFill>
+          <a:blip r:embed="rId2"/>
+          <a:stretch>
+            <a:fillRect/>
+          </a:stretch>
+        </p:blipFill>
+        <p:spPr>
+          <a:xfrm>
+            <a:off x="3133957" y="0"/>
+            <a:ext cx="5924085" cy="6858000"/>
+          </a:xfrm>
+          <a:prstGeom prst="rect">
+            <a:avLst/>
+          </a:prstGeom>
+        </p:spPr>
+      </p:pic>
+      <p:pic>
+        <p:nvPicPr>
+          <p:cNvPr id="5" name="Picture 4">
+            <a:extLst>
+              <a:ext uri="{FF2B5EF4-FFF2-40B4-BE49-F238E27FC236}">
+                <a16:creationId xmlns:a16="http://schemas.microsoft.com/office/drawing/2014/main" id="{84E730A5-C5F7-A624-46A2-1CA13CF498B5}"/>
+              </a:ext>
+            </a:extLst>
+          </p:cNvPr>
+          <p:cNvPicPr>
+            <a:picLocks noChangeAspect="1"/>
+          </p:cNvPicPr>
+          <p:nvPr/>
+        </p:nvPicPr>
+        <p:blipFill>
+          <a:blip r:embed="rId2"/>
+          <a:stretch>
+            <a:fillRect/>
+          </a:stretch>
+        </p:blipFill>
+        <p:spPr>
+          <a:xfrm>
+            <a:off x="3286357" y="152400"/>
+            <a:ext cx="5924085" cy="6858000"/>
+          </a:xfrm>
+          <a:prstGeom prst="rect">
+            <a:avLst/>
+          </a:prstGeom>
+        </p:spPr>
+      </p:pic>
     </p:spTree>
     <p:extLst>
       <p:ext uri="{BB962C8B-B14F-4D97-AF65-F5344CB8AC3E}">
         <p14:creationId xmlns:p14="http://schemas.microsoft.com/office/powerpoint/2010/main" val="3737127349"/>
+      </p:ext>
+    </p:extLst>
+  </p:cSld>
+  <p:clrMapOvr>
+    <a:masterClrMapping/>
+  </p:clrMapOvr>
+</p:sld>
+</file>
+
+<file path=ppt/slides/slide10.xml><?xml version="1.0" encoding="utf-8"?>
+<p:sld xmlns:a="http://schemas.openxmlformats.org/drawingml/2006/main" xmlns:r="http://schemas.openxmlformats.org/officeDocument/2006/relationships" xmlns:p="http://schemas.openxmlformats.org/presentationml/2006/main">
+  <p:cSld>
+    <p:spTree>
+      <p:nvGrpSpPr>
+        <p:cNvPr id="1" name="">
+          <a:extLst>
+            <a:ext uri="{FF2B5EF4-FFF2-40B4-BE49-F238E27FC236}">
+              <a16:creationId xmlns:a16="http://schemas.microsoft.com/office/drawing/2014/main" id="{639F3E4D-F155-FCFB-CBFC-A52A8F66406C}"/>
+            </a:ext>
+          </a:extLst>
+        </p:cNvPr>
+        <p:cNvGrpSpPr/>
+        <p:nvPr/>
+      </p:nvGrpSpPr>
+      <p:grpSpPr>
+        <a:xfrm>
+          <a:off x="0" y="0"/>
+          <a:ext cx="0" cy="0"/>
+          <a:chOff x="0" y="0"/>
+          <a:chExt cx="0" cy="0"/>
+        </a:xfrm>
+      </p:grpSpPr>
+      <p:sp>
+        <p:nvSpPr>
+          <p:cNvPr id="3" name="TextBox 2">
+            <a:extLst>
+              <a:ext uri="{FF2B5EF4-FFF2-40B4-BE49-F238E27FC236}">
+                <a16:creationId xmlns:a16="http://schemas.microsoft.com/office/drawing/2014/main" id="{50C1AAFE-DEE2-FA58-E41A-143711AAC927}"/>
+              </a:ext>
+            </a:extLst>
+          </p:cNvPr>
+          <p:cNvSpPr txBox="1"/>
+          <p:nvPr/>
+        </p:nvSpPr>
+        <p:spPr>
+          <a:xfrm>
+            <a:off x="0" y="0"/>
+            <a:ext cx="12192000" cy="355354"/>
+          </a:xfrm>
+          <a:prstGeom prst="rect">
+            <a:avLst/>
+          </a:prstGeom>
+          <a:noFill/>
+        </p:spPr>
+        <p:txBody>
+          <a:bodyPr wrap="square">
+            <a:spAutoFit/>
+          </a:bodyPr>
+          <a:lstStyle/>
+          <a:p>
+            <a:pPr>
+              <a:lnSpc>
+                <a:spcPct val="150000"/>
+              </a:lnSpc>
+              <a:buNone/>
+            </a:pPr>
+            <a:r>
+              <a:rPr kumimoji="0" lang="en-US" altLang="en-US" sz="1300" b="0" i="0" u="none" strike="noStrike" cap="none" normalizeH="0" baseline="0">
+                <a:ln>
+                  <a:noFill/>
+                </a:ln>
+                <a:solidFill>
+                  <a:schemeClr val="tx1"/>
+                </a:solidFill>
+                <a:effectLst/>
+                <a:latin typeface="Arial" panose="020B0604020202020204" pitchFamily="34" charset="0"/>
+              </a:rPr>
+              <a:t>.</a:t>
+            </a:r>
+          </a:p>
+        </p:txBody>
+      </p:sp>
+      <p:pic>
+        <p:nvPicPr>
+          <p:cNvPr id="4" name="Picture 3">
+            <a:extLst>
+              <a:ext uri="{FF2B5EF4-FFF2-40B4-BE49-F238E27FC236}">
+                <a16:creationId xmlns:a16="http://schemas.microsoft.com/office/drawing/2014/main" id="{7E719216-26CA-E674-1230-F943EA4E3BD8}"/>
+              </a:ext>
+            </a:extLst>
+          </p:cNvPr>
+          <p:cNvPicPr>
+            <a:picLocks noChangeAspect="1"/>
+          </p:cNvPicPr>
+          <p:nvPr/>
+        </p:nvPicPr>
+        <p:blipFill>
+          <a:blip r:embed="rId2"/>
+          <a:stretch>
+            <a:fillRect/>
+          </a:stretch>
+        </p:blipFill>
+        <p:spPr>
+          <a:xfrm>
+            <a:off x="0" y="1142203"/>
+            <a:ext cx="12192000" cy="4573593"/>
+          </a:xfrm>
+          <a:prstGeom prst="rect">
+            <a:avLst/>
+          </a:prstGeom>
+        </p:spPr>
+      </p:pic>
+    </p:spTree>
+    <p:extLst>
+      <p:ext uri="{BB962C8B-B14F-4D97-AF65-F5344CB8AC3E}">
+        <p14:creationId xmlns:p14="http://schemas.microsoft.com/office/powerpoint/2010/main" val="23365865"/>
+      </p:ext>
+    </p:extLst>
+  </p:cSld>
+  <p:clrMapOvr>
+    <a:masterClrMapping/>
+  </p:clrMapOvr>
+</p:sld>
+</file>
+
+<file path=ppt/slides/slide11.xml><?xml version="1.0" encoding="utf-8"?>
+<p:sld xmlns:a="http://schemas.openxmlformats.org/drawingml/2006/main" xmlns:r="http://schemas.openxmlformats.org/officeDocument/2006/relationships" xmlns:p="http://schemas.openxmlformats.org/presentationml/2006/main">
+  <p:cSld>
+    <p:spTree>
+      <p:nvGrpSpPr>
+        <p:cNvPr id="1" name="">
+          <a:extLst>
+            <a:ext uri="{FF2B5EF4-FFF2-40B4-BE49-F238E27FC236}">
+              <a16:creationId xmlns:a16="http://schemas.microsoft.com/office/drawing/2014/main" id="{87DF816D-A4BF-D978-E7B0-A292097B911A}"/>
+            </a:ext>
+          </a:extLst>
+        </p:cNvPr>
+        <p:cNvGrpSpPr/>
+        <p:nvPr/>
+      </p:nvGrpSpPr>
+      <p:grpSpPr>
+        <a:xfrm>
+          <a:off x="0" y="0"/>
+          <a:ext cx="0" cy="0"/>
+          <a:chOff x="0" y="0"/>
+          <a:chExt cx="0" cy="0"/>
+        </a:xfrm>
+      </p:grpSpPr>
+      <p:sp>
+        <p:nvSpPr>
+          <p:cNvPr id="3" name="TextBox 2">
+            <a:extLst>
+              <a:ext uri="{FF2B5EF4-FFF2-40B4-BE49-F238E27FC236}">
+                <a16:creationId xmlns:a16="http://schemas.microsoft.com/office/drawing/2014/main" id="{4155427F-1AC4-F481-B8EB-02BFC5BC5C3D}"/>
+              </a:ext>
+            </a:extLst>
+          </p:cNvPr>
+          <p:cNvSpPr txBox="1"/>
+          <p:nvPr/>
+        </p:nvSpPr>
+        <p:spPr>
+          <a:xfrm>
+            <a:off x="0" y="0"/>
+            <a:ext cx="12192000" cy="355354"/>
+          </a:xfrm>
+          <a:prstGeom prst="rect">
+            <a:avLst/>
+          </a:prstGeom>
+          <a:noFill/>
+        </p:spPr>
+        <p:txBody>
+          <a:bodyPr wrap="square">
+            <a:spAutoFit/>
+          </a:bodyPr>
+          <a:lstStyle/>
+          <a:p>
+            <a:pPr>
+              <a:lnSpc>
+                <a:spcPct val="150000"/>
+              </a:lnSpc>
+              <a:buNone/>
+            </a:pPr>
+            <a:r>
+              <a:rPr kumimoji="0" lang="en-US" altLang="en-US" sz="1300" b="0" i="0" u="none" strike="noStrike" cap="none" normalizeH="0" baseline="0">
+                <a:ln>
+                  <a:noFill/>
+                </a:ln>
+                <a:solidFill>
+                  <a:schemeClr val="tx1"/>
+                </a:solidFill>
+                <a:effectLst/>
+                <a:latin typeface="Arial" panose="020B0604020202020204" pitchFamily="34" charset="0"/>
+              </a:rPr>
+              <a:t>.</a:t>
+            </a:r>
+          </a:p>
+        </p:txBody>
+      </p:sp>
+      <p:pic>
+        <p:nvPicPr>
+          <p:cNvPr id="4" name="Picture 3">
+            <a:extLst>
+              <a:ext uri="{FF2B5EF4-FFF2-40B4-BE49-F238E27FC236}">
+                <a16:creationId xmlns:a16="http://schemas.microsoft.com/office/drawing/2014/main" id="{57AD9813-2C50-FBA8-8333-D44D956A7BB3}"/>
+              </a:ext>
+            </a:extLst>
+          </p:cNvPr>
+          <p:cNvPicPr>
+            <a:picLocks noChangeAspect="1"/>
+          </p:cNvPicPr>
+          <p:nvPr/>
+        </p:nvPicPr>
+        <p:blipFill>
+          <a:blip r:embed="rId2"/>
+          <a:stretch>
+            <a:fillRect/>
+          </a:stretch>
+        </p:blipFill>
+        <p:spPr>
+          <a:xfrm>
+            <a:off x="0" y="1025033"/>
+            <a:ext cx="12192000" cy="4807933"/>
+          </a:xfrm>
+          <a:prstGeom prst="rect">
+            <a:avLst/>
+          </a:prstGeom>
+          <a:solidFill>
+            <a:srgbClr val="FFFFFF">
+              <a:shade val="85000"/>
+            </a:srgbClr>
+          </a:solidFill>
+          <a:ln w="88900" cap="sq">
+            <a:solidFill>
+              <a:srgbClr val="FFFFFF"/>
+            </a:solidFill>
+            <a:miter lim="800000"/>
+          </a:ln>
+          <a:effectLst>
+            <a:outerShdw blurRad="55000" dist="18000" dir="5400000" algn="tl" rotWithShape="0">
+              <a:srgbClr val="000000">
+                <a:alpha val="40000"/>
+              </a:srgbClr>
+            </a:outerShdw>
+          </a:effectLst>
+          <a:scene3d>
+            <a:camera prst="orthographicFront"/>
+            <a:lightRig rig="twoPt" dir="t">
+              <a:rot lat="0" lon="0" rev="7200000"/>
+            </a:lightRig>
+          </a:scene3d>
+          <a:sp3d>
+            <a:bevelT w="25400" h="19050"/>
+            <a:contourClr>
+              <a:srgbClr val="FFFFFF"/>
+            </a:contourClr>
+          </a:sp3d>
+        </p:spPr>
+      </p:pic>
+    </p:spTree>
+    <p:extLst>
+      <p:ext uri="{BB962C8B-B14F-4D97-AF65-F5344CB8AC3E}">
+        <p14:creationId xmlns:p14="http://schemas.microsoft.com/office/powerpoint/2010/main" val="3718529565"/>
+      </p:ext>
+    </p:extLst>
+  </p:cSld>
+  <p:clrMapOvr>
+    <a:masterClrMapping/>
+  </p:clrMapOvr>
+</p:sld>
+</file>
+
+<file path=ppt/slides/slide12.xml><?xml version="1.0" encoding="utf-8"?>
+<p:sld xmlns:a="http://schemas.openxmlformats.org/drawingml/2006/main" xmlns:r="http://schemas.openxmlformats.org/officeDocument/2006/relationships" xmlns:p="http://schemas.openxmlformats.org/presentationml/2006/main">
+  <p:cSld>
+    <p:spTree>
+      <p:nvGrpSpPr>
+        <p:cNvPr id="1" name="">
+          <a:extLst>
+            <a:ext uri="{FF2B5EF4-FFF2-40B4-BE49-F238E27FC236}">
+              <a16:creationId xmlns:a16="http://schemas.microsoft.com/office/drawing/2014/main" id="{C1FB020F-B938-DE1D-8188-3D732E913939}"/>
+            </a:ext>
+          </a:extLst>
+        </p:cNvPr>
+        <p:cNvGrpSpPr/>
+        <p:nvPr/>
+      </p:nvGrpSpPr>
+      <p:grpSpPr>
+        <a:xfrm>
+          <a:off x="0" y="0"/>
+          <a:ext cx="0" cy="0"/>
+          <a:chOff x="0" y="0"/>
+          <a:chExt cx="0" cy="0"/>
+        </a:xfrm>
+      </p:grpSpPr>
+      <p:sp>
+        <p:nvSpPr>
+          <p:cNvPr id="3" name="TextBox 2">
+            <a:extLst>
+              <a:ext uri="{FF2B5EF4-FFF2-40B4-BE49-F238E27FC236}">
+                <a16:creationId xmlns:a16="http://schemas.microsoft.com/office/drawing/2014/main" id="{3A6C0905-57DA-E8FA-3EC4-0B87E3EE13AB}"/>
+              </a:ext>
+            </a:extLst>
+          </p:cNvPr>
+          <p:cNvSpPr txBox="1"/>
+          <p:nvPr/>
+        </p:nvSpPr>
+        <p:spPr>
+          <a:xfrm>
+            <a:off x="0" y="0"/>
+            <a:ext cx="12192000" cy="355354"/>
+          </a:xfrm>
+          <a:prstGeom prst="rect">
+            <a:avLst/>
+          </a:prstGeom>
+          <a:noFill/>
+        </p:spPr>
+        <p:txBody>
+          <a:bodyPr wrap="square">
+            <a:spAutoFit/>
+          </a:bodyPr>
+          <a:lstStyle/>
+          <a:p>
+            <a:pPr>
+              <a:lnSpc>
+                <a:spcPct val="150000"/>
+              </a:lnSpc>
+              <a:buNone/>
+            </a:pPr>
+            <a:r>
+              <a:rPr kumimoji="0" lang="en-US" altLang="en-US" sz="1300" b="0" i="0" u="none" strike="noStrike" cap="none" normalizeH="0" baseline="0">
+                <a:ln>
+                  <a:noFill/>
+                </a:ln>
+                <a:solidFill>
+                  <a:schemeClr val="tx1"/>
+                </a:solidFill>
+                <a:effectLst/>
+                <a:latin typeface="Arial" panose="020B0604020202020204" pitchFamily="34" charset="0"/>
+              </a:rPr>
+              <a:t>.</a:t>
+            </a:r>
+          </a:p>
+        </p:txBody>
+      </p:sp>
+      <p:pic>
+        <p:nvPicPr>
+          <p:cNvPr id="4" name="Picture 3">
+            <a:extLst>
+              <a:ext uri="{FF2B5EF4-FFF2-40B4-BE49-F238E27FC236}">
+                <a16:creationId xmlns:a16="http://schemas.microsoft.com/office/drawing/2014/main" id="{6F3C511A-56F4-1E75-210C-F050B3F87185}"/>
+              </a:ext>
+            </a:extLst>
+          </p:cNvPr>
+          <p:cNvPicPr>
+            <a:picLocks noChangeAspect="1"/>
+          </p:cNvPicPr>
+          <p:nvPr/>
+        </p:nvPicPr>
+        <p:blipFill>
+          <a:blip r:embed="rId2"/>
+          <a:stretch>
+            <a:fillRect/>
+          </a:stretch>
+        </p:blipFill>
+        <p:spPr>
+          <a:xfrm>
+            <a:off x="0" y="1392764"/>
+            <a:ext cx="12192000" cy="4072471"/>
+          </a:xfrm>
+          <a:prstGeom prst="rect">
+            <a:avLst/>
+          </a:prstGeom>
+          <a:solidFill>
+            <a:srgbClr val="FFFFFF">
+              <a:shade val="85000"/>
+            </a:srgbClr>
+          </a:solidFill>
+          <a:ln w="88900" cap="sq">
+            <a:solidFill>
+              <a:srgbClr val="FFFFFF"/>
+            </a:solidFill>
+            <a:miter lim="800000"/>
+          </a:ln>
+          <a:effectLst>
+            <a:outerShdw blurRad="55000" dist="18000" dir="5400000" algn="tl" rotWithShape="0">
+              <a:srgbClr val="000000">
+                <a:alpha val="40000"/>
+              </a:srgbClr>
+            </a:outerShdw>
+          </a:effectLst>
+          <a:scene3d>
+            <a:camera prst="orthographicFront"/>
+            <a:lightRig rig="twoPt" dir="t">
+              <a:rot lat="0" lon="0" rev="7200000"/>
+            </a:lightRig>
+          </a:scene3d>
+          <a:sp3d>
+            <a:bevelT w="25400" h="19050"/>
+            <a:contourClr>
+              <a:srgbClr val="FFFFFF"/>
+            </a:contourClr>
+          </a:sp3d>
+        </p:spPr>
+      </p:pic>
+    </p:spTree>
+    <p:extLst>
+      <p:ext uri="{BB962C8B-B14F-4D97-AF65-F5344CB8AC3E}">
+        <p14:creationId xmlns:p14="http://schemas.microsoft.com/office/powerpoint/2010/main" val="1839686703"/>
+      </p:ext>
+    </p:extLst>
+  </p:cSld>
+  <p:clrMapOvr>
+    <a:masterClrMapping/>
+  </p:clrMapOvr>
+</p:sld>
+</file>
+
+<file path=ppt/slides/slide13.xml><?xml version="1.0" encoding="utf-8"?>
+<p:sld xmlns:a="http://schemas.openxmlformats.org/drawingml/2006/main" xmlns:r="http://schemas.openxmlformats.org/officeDocument/2006/relationships" xmlns:p="http://schemas.openxmlformats.org/presentationml/2006/main">
+  <p:cSld>
+    <p:spTree>
+      <p:nvGrpSpPr>
+        <p:cNvPr id="1" name="">
+          <a:extLst>
+            <a:ext uri="{FF2B5EF4-FFF2-40B4-BE49-F238E27FC236}">
+              <a16:creationId xmlns:a16="http://schemas.microsoft.com/office/drawing/2014/main" id="{E04A9DDF-CB06-1E3D-5A3B-54EA2ACCED9D}"/>
+            </a:ext>
+          </a:extLst>
+        </p:cNvPr>
+        <p:cNvGrpSpPr/>
+        <p:nvPr/>
+      </p:nvGrpSpPr>
+      <p:grpSpPr>
+        <a:xfrm>
+          <a:off x="0" y="0"/>
+          <a:ext cx="0" cy="0"/>
+          <a:chOff x="0" y="0"/>
+          <a:chExt cx="0" cy="0"/>
+        </a:xfrm>
+      </p:grpSpPr>
+      <p:sp>
+        <p:nvSpPr>
+          <p:cNvPr id="3" name="TextBox 2">
+            <a:extLst>
+              <a:ext uri="{FF2B5EF4-FFF2-40B4-BE49-F238E27FC236}">
+                <a16:creationId xmlns:a16="http://schemas.microsoft.com/office/drawing/2014/main" id="{059ABF4B-8411-16D9-A852-F8B2B1C60E15}"/>
+              </a:ext>
+            </a:extLst>
+          </p:cNvPr>
+          <p:cNvSpPr txBox="1"/>
+          <p:nvPr/>
+        </p:nvSpPr>
+        <p:spPr>
+          <a:xfrm>
+            <a:off x="0" y="0"/>
+            <a:ext cx="12192000" cy="355354"/>
+          </a:xfrm>
+          <a:prstGeom prst="rect">
+            <a:avLst/>
+          </a:prstGeom>
+          <a:noFill/>
+        </p:spPr>
+        <p:txBody>
+          <a:bodyPr wrap="square">
+            <a:spAutoFit/>
+          </a:bodyPr>
+          <a:lstStyle/>
+          <a:p>
+            <a:pPr>
+              <a:lnSpc>
+                <a:spcPct val="150000"/>
+              </a:lnSpc>
+              <a:buNone/>
+            </a:pPr>
+            <a:r>
+              <a:rPr kumimoji="0" lang="en-US" altLang="en-US" sz="1300" b="0" i="0" u="none" strike="noStrike" cap="none" normalizeH="0" baseline="0">
+                <a:ln>
+                  <a:noFill/>
+                </a:ln>
+                <a:solidFill>
+                  <a:schemeClr val="tx1"/>
+                </a:solidFill>
+                <a:effectLst/>
+                <a:latin typeface="Arial" panose="020B0604020202020204" pitchFamily="34" charset="0"/>
+              </a:rPr>
+              <a:t>.</a:t>
+            </a:r>
+          </a:p>
+        </p:txBody>
+      </p:sp>
+      <p:pic>
+        <p:nvPicPr>
+          <p:cNvPr id="4" name="Picture 3">
+            <a:extLst>
+              <a:ext uri="{FF2B5EF4-FFF2-40B4-BE49-F238E27FC236}">
+                <a16:creationId xmlns:a16="http://schemas.microsoft.com/office/drawing/2014/main" id="{C7BFE759-E7D2-4783-D73A-13960842669A}"/>
+              </a:ext>
+            </a:extLst>
+          </p:cNvPr>
+          <p:cNvPicPr>
+            <a:picLocks noChangeAspect="1"/>
+          </p:cNvPicPr>
+          <p:nvPr/>
+        </p:nvPicPr>
+        <p:blipFill>
+          <a:blip r:embed="rId2"/>
+          <a:stretch>
+            <a:fillRect/>
+          </a:stretch>
+        </p:blipFill>
+        <p:spPr>
+          <a:xfrm>
+            <a:off x="2551651" y="0"/>
+            <a:ext cx="7088697" cy="6858000"/>
+          </a:xfrm>
+          <a:prstGeom prst="rect">
+            <a:avLst/>
+          </a:prstGeom>
+        </p:spPr>
+      </p:pic>
+    </p:spTree>
+    <p:extLst>
+      <p:ext uri="{BB962C8B-B14F-4D97-AF65-F5344CB8AC3E}">
+        <p14:creationId xmlns:p14="http://schemas.microsoft.com/office/powerpoint/2010/main" val="2388642893"/>
+      </p:ext>
+    </p:extLst>
+  </p:cSld>
+  <p:clrMapOvr>
+    <a:masterClrMapping/>
+  </p:clrMapOvr>
+</p:sld>
+</file>
+
+<file path=ppt/slides/slide14.xml><?xml version="1.0" encoding="utf-8"?>
+<p:sld xmlns:a="http://schemas.openxmlformats.org/drawingml/2006/main" xmlns:r="http://schemas.openxmlformats.org/officeDocument/2006/relationships" xmlns:p="http://schemas.openxmlformats.org/presentationml/2006/main">
+  <p:cSld>
+    <p:spTree>
+      <p:nvGrpSpPr>
+        <p:cNvPr id="1" name="">
+          <a:extLst>
+            <a:ext uri="{FF2B5EF4-FFF2-40B4-BE49-F238E27FC236}">
+              <a16:creationId xmlns:a16="http://schemas.microsoft.com/office/drawing/2014/main" id="{8A221BF1-63CC-86E7-403B-04D6719FD17D}"/>
+            </a:ext>
+          </a:extLst>
+        </p:cNvPr>
+        <p:cNvGrpSpPr/>
+        <p:nvPr/>
+      </p:nvGrpSpPr>
+      <p:grpSpPr>
+        <a:xfrm>
+          <a:off x="0" y="0"/>
+          <a:ext cx="0" cy="0"/>
+          <a:chOff x="0" y="0"/>
+          <a:chExt cx="0" cy="0"/>
+        </a:xfrm>
+      </p:grpSpPr>
+      <p:sp>
+        <p:nvSpPr>
+          <p:cNvPr id="3" name="TextBox 2">
+            <a:extLst>
+              <a:ext uri="{FF2B5EF4-FFF2-40B4-BE49-F238E27FC236}">
+                <a16:creationId xmlns:a16="http://schemas.microsoft.com/office/drawing/2014/main" id="{D0329668-BCDD-E429-F883-2DD4069B2533}"/>
+              </a:ext>
+            </a:extLst>
+          </p:cNvPr>
+          <p:cNvSpPr txBox="1"/>
+          <p:nvPr/>
+        </p:nvSpPr>
+        <p:spPr>
+          <a:xfrm>
+            <a:off x="0" y="0"/>
+            <a:ext cx="12192000" cy="355354"/>
+          </a:xfrm>
+          <a:prstGeom prst="rect">
+            <a:avLst/>
+          </a:prstGeom>
+          <a:noFill/>
+        </p:spPr>
+        <p:txBody>
+          <a:bodyPr wrap="square">
+            <a:spAutoFit/>
+          </a:bodyPr>
+          <a:lstStyle/>
+          <a:p>
+            <a:pPr>
+              <a:lnSpc>
+                <a:spcPct val="150000"/>
+              </a:lnSpc>
+              <a:buNone/>
+            </a:pPr>
+            <a:r>
+              <a:rPr kumimoji="0" lang="en-US" altLang="en-US" sz="1300" b="0" i="0" u="none" strike="noStrike" cap="none" normalizeH="0" baseline="0">
+                <a:ln>
+                  <a:noFill/>
+                </a:ln>
+                <a:solidFill>
+                  <a:schemeClr val="tx1"/>
+                </a:solidFill>
+                <a:effectLst/>
+                <a:latin typeface="Arial" panose="020B0604020202020204" pitchFamily="34" charset="0"/>
+              </a:rPr>
+              <a:t>.</a:t>
+            </a:r>
+          </a:p>
+        </p:txBody>
+      </p:sp>
+      <p:pic>
+        <p:nvPicPr>
+          <p:cNvPr id="4" name="Picture 3">
+            <a:extLst>
+              <a:ext uri="{FF2B5EF4-FFF2-40B4-BE49-F238E27FC236}">
+                <a16:creationId xmlns:a16="http://schemas.microsoft.com/office/drawing/2014/main" id="{2AAA671B-7DE4-2145-ABA7-9FC45116CB9D}"/>
+              </a:ext>
+            </a:extLst>
+          </p:cNvPr>
+          <p:cNvPicPr>
+            <a:picLocks noChangeAspect="1"/>
+          </p:cNvPicPr>
+          <p:nvPr/>
+        </p:nvPicPr>
+        <p:blipFill>
+          <a:blip r:embed="rId2"/>
+          <a:stretch>
+            <a:fillRect/>
+          </a:stretch>
+        </p:blipFill>
+        <p:spPr>
+          <a:xfrm>
+            <a:off x="0" y="126717"/>
+            <a:ext cx="12192000" cy="6604565"/>
+          </a:xfrm>
+          <a:prstGeom prst="rect">
+            <a:avLst/>
+          </a:prstGeom>
+        </p:spPr>
+      </p:pic>
+    </p:spTree>
+    <p:extLst>
+      <p:ext uri="{BB962C8B-B14F-4D97-AF65-F5344CB8AC3E}">
+        <p14:creationId xmlns:p14="http://schemas.microsoft.com/office/powerpoint/2010/main" val="964539186"/>
+      </p:ext>
+    </p:extLst>
+  </p:cSld>
+  <p:clrMapOvr>
+    <a:masterClrMapping/>
+  </p:clrMapOvr>
+</p:sld>
+</file>
+
+<file path=ppt/slides/slide15.xml><?xml version="1.0" encoding="utf-8"?>
+<p:sld xmlns:a="http://schemas.openxmlformats.org/drawingml/2006/main" xmlns:r="http://schemas.openxmlformats.org/officeDocument/2006/relationships" xmlns:p="http://schemas.openxmlformats.org/presentationml/2006/main">
+  <p:cSld>
+    <p:spTree>
+      <p:nvGrpSpPr>
+        <p:cNvPr id="1" name="">
+          <a:extLst>
+            <a:ext uri="{FF2B5EF4-FFF2-40B4-BE49-F238E27FC236}">
+              <a16:creationId xmlns:a16="http://schemas.microsoft.com/office/drawing/2014/main" id="{08209966-0DA3-AFF0-832A-0A49C2018CF8}"/>
+            </a:ext>
+          </a:extLst>
+        </p:cNvPr>
+        <p:cNvGrpSpPr/>
+        <p:nvPr/>
+      </p:nvGrpSpPr>
+      <p:grpSpPr>
+        <a:xfrm>
+          <a:off x="0" y="0"/>
+          <a:ext cx="0" cy="0"/>
+          <a:chOff x="0" y="0"/>
+          <a:chExt cx="0" cy="0"/>
+        </a:xfrm>
+      </p:grpSpPr>
+      <p:sp>
+        <p:nvSpPr>
+          <p:cNvPr id="3" name="TextBox 2">
+            <a:extLst>
+              <a:ext uri="{FF2B5EF4-FFF2-40B4-BE49-F238E27FC236}">
+                <a16:creationId xmlns:a16="http://schemas.microsoft.com/office/drawing/2014/main" id="{7BBF29BD-87A3-97A9-B088-93D37451834A}"/>
+              </a:ext>
+            </a:extLst>
+          </p:cNvPr>
+          <p:cNvSpPr txBox="1"/>
+          <p:nvPr/>
+        </p:nvSpPr>
+        <p:spPr>
+          <a:xfrm>
+            <a:off x="0" y="0"/>
+            <a:ext cx="12192000" cy="355354"/>
+          </a:xfrm>
+          <a:prstGeom prst="rect">
+            <a:avLst/>
+          </a:prstGeom>
+          <a:noFill/>
+        </p:spPr>
+        <p:txBody>
+          <a:bodyPr wrap="square">
+            <a:spAutoFit/>
+          </a:bodyPr>
+          <a:lstStyle/>
+          <a:p>
+            <a:pPr>
+              <a:lnSpc>
+                <a:spcPct val="150000"/>
+              </a:lnSpc>
+              <a:buNone/>
+            </a:pPr>
+            <a:r>
+              <a:rPr kumimoji="0" lang="en-US" altLang="en-US" sz="1300" b="0" i="0" u="none" strike="noStrike" cap="none" normalizeH="0" baseline="0">
+                <a:ln>
+                  <a:noFill/>
+                </a:ln>
+                <a:solidFill>
+                  <a:schemeClr val="tx1"/>
+                </a:solidFill>
+                <a:effectLst/>
+                <a:latin typeface="Arial" panose="020B0604020202020204" pitchFamily="34" charset="0"/>
+              </a:rPr>
+              <a:t>.</a:t>
+            </a:r>
+          </a:p>
+        </p:txBody>
+      </p:sp>
+      <p:pic>
+        <p:nvPicPr>
+          <p:cNvPr id="4" name="Picture 3">
+            <a:extLst>
+              <a:ext uri="{FF2B5EF4-FFF2-40B4-BE49-F238E27FC236}">
+                <a16:creationId xmlns:a16="http://schemas.microsoft.com/office/drawing/2014/main" id="{8D92AFC7-5202-FA07-C958-C10224B67D24}"/>
+              </a:ext>
+            </a:extLst>
+          </p:cNvPr>
+          <p:cNvPicPr>
+            <a:picLocks noChangeAspect="1"/>
+          </p:cNvPicPr>
+          <p:nvPr/>
+        </p:nvPicPr>
+        <p:blipFill>
+          <a:blip r:embed="rId2"/>
+          <a:stretch>
+            <a:fillRect/>
+          </a:stretch>
+        </p:blipFill>
+        <p:spPr>
+          <a:xfrm>
+            <a:off x="1058825" y="0"/>
+            <a:ext cx="10074349" cy="6858000"/>
+          </a:xfrm>
+          <a:prstGeom prst="rect">
+            <a:avLst/>
+          </a:prstGeom>
+          <a:solidFill>
+            <a:srgbClr val="FFFFFF">
+              <a:shade val="85000"/>
+            </a:srgbClr>
+          </a:solidFill>
+          <a:ln w="88900" cap="sq">
+            <a:solidFill>
+              <a:srgbClr val="FFFFFF"/>
+            </a:solidFill>
+            <a:miter lim="800000"/>
+          </a:ln>
+          <a:effectLst>
+            <a:outerShdw blurRad="55000" dist="18000" dir="5400000" algn="tl" rotWithShape="0">
+              <a:srgbClr val="000000">
+                <a:alpha val="40000"/>
+              </a:srgbClr>
+            </a:outerShdw>
+          </a:effectLst>
+          <a:scene3d>
+            <a:camera prst="orthographicFront"/>
+            <a:lightRig rig="twoPt" dir="t">
+              <a:rot lat="0" lon="0" rev="7200000"/>
+            </a:lightRig>
+          </a:scene3d>
+          <a:sp3d>
+            <a:bevelT w="25400" h="19050"/>
+            <a:contourClr>
+              <a:srgbClr val="FFFFFF"/>
+            </a:contourClr>
+          </a:sp3d>
+        </p:spPr>
+      </p:pic>
+    </p:spTree>
+    <p:extLst>
+      <p:ext uri="{BB962C8B-B14F-4D97-AF65-F5344CB8AC3E}">
+        <p14:creationId xmlns:p14="http://schemas.microsoft.com/office/powerpoint/2010/main" val="2338400995"/>
+      </p:ext>
+    </p:extLst>
+  </p:cSld>
+  <p:clrMapOvr>
+    <a:masterClrMapping/>
+  </p:clrMapOvr>
+</p:sld>
+</file>
+
+<file path=ppt/slides/slide16.xml><?xml version="1.0" encoding="utf-8"?>
+<p:sld xmlns:a="http://schemas.openxmlformats.org/drawingml/2006/main" xmlns:r="http://schemas.openxmlformats.org/officeDocument/2006/relationships" xmlns:p="http://schemas.openxmlformats.org/presentationml/2006/main">
+  <p:cSld>
+    <p:spTree>
+      <p:nvGrpSpPr>
+        <p:cNvPr id="1" name="">
+          <a:extLst>
+            <a:ext uri="{FF2B5EF4-FFF2-40B4-BE49-F238E27FC236}">
+              <a16:creationId xmlns:a16="http://schemas.microsoft.com/office/drawing/2014/main" id="{164E0137-CCCE-C273-FFDB-77559232E099}"/>
+            </a:ext>
+          </a:extLst>
+        </p:cNvPr>
+        <p:cNvGrpSpPr/>
+        <p:nvPr/>
+      </p:nvGrpSpPr>
+      <p:grpSpPr>
+        <a:xfrm>
+          <a:off x="0" y="0"/>
+          <a:ext cx="0" cy="0"/>
+          <a:chOff x="0" y="0"/>
+          <a:chExt cx="0" cy="0"/>
+        </a:xfrm>
+      </p:grpSpPr>
+      <p:sp>
+        <p:nvSpPr>
+          <p:cNvPr id="3" name="TextBox 2">
+            <a:extLst>
+              <a:ext uri="{FF2B5EF4-FFF2-40B4-BE49-F238E27FC236}">
+                <a16:creationId xmlns:a16="http://schemas.microsoft.com/office/drawing/2014/main" id="{FF727487-4B19-9D17-9E7E-39EE7AF5E31C}"/>
+              </a:ext>
+            </a:extLst>
+          </p:cNvPr>
+          <p:cNvSpPr txBox="1"/>
+          <p:nvPr/>
+        </p:nvSpPr>
+        <p:spPr>
+          <a:xfrm>
+            <a:off x="0" y="0"/>
+            <a:ext cx="12192000" cy="355354"/>
+          </a:xfrm>
+          <a:prstGeom prst="rect">
+            <a:avLst/>
+          </a:prstGeom>
+          <a:noFill/>
+        </p:spPr>
+        <p:txBody>
+          <a:bodyPr wrap="square">
+            <a:spAutoFit/>
+          </a:bodyPr>
+          <a:lstStyle/>
+          <a:p>
+            <a:pPr>
+              <a:lnSpc>
+                <a:spcPct val="150000"/>
+              </a:lnSpc>
+              <a:buNone/>
+            </a:pPr>
+            <a:r>
+              <a:rPr kumimoji="0" lang="en-US" altLang="en-US" sz="1300" b="0" i="0" u="none" strike="noStrike" cap="none" normalizeH="0" baseline="0">
+                <a:ln>
+                  <a:noFill/>
+                </a:ln>
+                <a:solidFill>
+                  <a:schemeClr val="tx1"/>
+                </a:solidFill>
+                <a:effectLst/>
+                <a:latin typeface="Arial" panose="020B0604020202020204" pitchFamily="34" charset="0"/>
+              </a:rPr>
+              <a:t>.</a:t>
+            </a:r>
+          </a:p>
+        </p:txBody>
+      </p:sp>
+      <p:pic>
+        <p:nvPicPr>
+          <p:cNvPr id="4" name="Picture 3">
+            <a:extLst>
+              <a:ext uri="{FF2B5EF4-FFF2-40B4-BE49-F238E27FC236}">
+                <a16:creationId xmlns:a16="http://schemas.microsoft.com/office/drawing/2014/main" id="{23E76D43-9113-C28D-1DF7-CE2351C1E44B}"/>
+              </a:ext>
+            </a:extLst>
+          </p:cNvPr>
+          <p:cNvPicPr>
+            <a:picLocks noChangeAspect="1"/>
+          </p:cNvPicPr>
+          <p:nvPr/>
+        </p:nvPicPr>
+        <p:blipFill>
+          <a:blip r:embed="rId2"/>
+          <a:stretch>
+            <a:fillRect/>
+          </a:stretch>
+        </p:blipFill>
+        <p:spPr>
+          <a:xfrm>
+            <a:off x="1948976" y="0"/>
+            <a:ext cx="8294047" cy="6858000"/>
+          </a:xfrm>
+          <a:prstGeom prst="rect">
+            <a:avLst/>
+          </a:prstGeom>
+        </p:spPr>
+      </p:pic>
+    </p:spTree>
+    <p:extLst>
+      <p:ext uri="{BB962C8B-B14F-4D97-AF65-F5344CB8AC3E}">
+        <p14:creationId xmlns:p14="http://schemas.microsoft.com/office/powerpoint/2010/main" val="556072844"/>
+      </p:ext>
+    </p:extLst>
+  </p:cSld>
+  <p:clrMapOvr>
+    <a:masterClrMapping/>
+  </p:clrMapOvr>
+</p:sld>
+</file>
+
+<file path=ppt/slides/slide17.xml><?xml version="1.0" encoding="utf-8"?>
+<p:sld xmlns:a="http://schemas.openxmlformats.org/drawingml/2006/main" xmlns:r="http://schemas.openxmlformats.org/officeDocument/2006/relationships" xmlns:p="http://schemas.openxmlformats.org/presentationml/2006/main">
+  <p:cSld>
+    <p:spTree>
+      <p:nvGrpSpPr>
+        <p:cNvPr id="1" name="">
+          <a:extLst>
+            <a:ext uri="{FF2B5EF4-FFF2-40B4-BE49-F238E27FC236}">
+              <a16:creationId xmlns:a16="http://schemas.microsoft.com/office/drawing/2014/main" id="{9406253F-D313-86CE-382B-7226FB857DF2}"/>
+            </a:ext>
+          </a:extLst>
+        </p:cNvPr>
+        <p:cNvGrpSpPr/>
+        <p:nvPr/>
+      </p:nvGrpSpPr>
+      <p:grpSpPr>
+        <a:xfrm>
+          <a:off x="0" y="0"/>
+          <a:ext cx="0" cy="0"/>
+          <a:chOff x="0" y="0"/>
+          <a:chExt cx="0" cy="0"/>
+        </a:xfrm>
+      </p:grpSpPr>
+      <p:sp>
+        <p:nvSpPr>
+          <p:cNvPr id="3" name="TextBox 2">
+            <a:extLst>
+              <a:ext uri="{FF2B5EF4-FFF2-40B4-BE49-F238E27FC236}">
+                <a16:creationId xmlns:a16="http://schemas.microsoft.com/office/drawing/2014/main" id="{D44E2950-2DCF-D011-2EA8-BF9E5EAE0BD3}"/>
+              </a:ext>
+            </a:extLst>
+          </p:cNvPr>
+          <p:cNvSpPr txBox="1"/>
+          <p:nvPr/>
+        </p:nvSpPr>
+        <p:spPr>
+          <a:xfrm>
+            <a:off x="0" y="0"/>
+            <a:ext cx="12192000" cy="355354"/>
+          </a:xfrm>
+          <a:prstGeom prst="rect">
+            <a:avLst/>
+          </a:prstGeom>
+          <a:noFill/>
+        </p:spPr>
+        <p:txBody>
+          <a:bodyPr wrap="square">
+            <a:spAutoFit/>
+          </a:bodyPr>
+          <a:lstStyle/>
+          <a:p>
+            <a:pPr>
+              <a:lnSpc>
+                <a:spcPct val="150000"/>
+              </a:lnSpc>
+              <a:buNone/>
+            </a:pPr>
+            <a:r>
+              <a:rPr kumimoji="0" lang="en-US" altLang="en-US" sz="1300" b="0" i="0" u="none" strike="noStrike" cap="none" normalizeH="0" baseline="0">
+                <a:ln>
+                  <a:noFill/>
+                </a:ln>
+                <a:solidFill>
+                  <a:schemeClr val="tx1"/>
+                </a:solidFill>
+                <a:effectLst/>
+                <a:latin typeface="Arial" panose="020B0604020202020204" pitchFamily="34" charset="0"/>
+              </a:rPr>
+              <a:t>.</a:t>
+            </a:r>
+          </a:p>
+        </p:txBody>
+      </p:sp>
+      <p:pic>
+        <p:nvPicPr>
+          <p:cNvPr id="4" name="Picture 3">
+            <a:extLst>
+              <a:ext uri="{FF2B5EF4-FFF2-40B4-BE49-F238E27FC236}">
+                <a16:creationId xmlns:a16="http://schemas.microsoft.com/office/drawing/2014/main" id="{5C4CE54A-9451-DDC1-8D93-FC0DDB773D3F}"/>
+              </a:ext>
+            </a:extLst>
+          </p:cNvPr>
+          <p:cNvPicPr>
+            <a:picLocks noChangeAspect="1"/>
+          </p:cNvPicPr>
+          <p:nvPr/>
+        </p:nvPicPr>
+        <p:blipFill>
+          <a:blip r:embed="rId2"/>
+          <a:stretch>
+            <a:fillRect/>
+          </a:stretch>
+        </p:blipFill>
+        <p:spPr>
+          <a:xfrm>
+            <a:off x="1619250" y="0"/>
+            <a:ext cx="8953500" cy="6858000"/>
+          </a:xfrm>
+          <a:prstGeom prst="rect">
+            <a:avLst/>
+          </a:prstGeom>
+        </p:spPr>
+      </p:pic>
+    </p:spTree>
+    <p:extLst>
+      <p:ext uri="{BB962C8B-B14F-4D97-AF65-F5344CB8AC3E}">
+        <p14:creationId xmlns:p14="http://schemas.microsoft.com/office/powerpoint/2010/main" val="3699930529"/>
+      </p:ext>
+    </p:extLst>
+  </p:cSld>
+  <p:clrMapOvr>
+    <a:masterClrMapping/>
+  </p:clrMapOvr>
+</p:sld>
+</file>
+
+<file path=ppt/slides/slide18.xml><?xml version="1.0" encoding="utf-8"?>
+<p:sld xmlns:a="http://schemas.openxmlformats.org/drawingml/2006/main" xmlns:r="http://schemas.openxmlformats.org/officeDocument/2006/relationships" xmlns:p="http://schemas.openxmlformats.org/presentationml/2006/main">
+  <p:cSld>
+    <p:spTree>
+      <p:nvGrpSpPr>
+        <p:cNvPr id="1" name="">
+          <a:extLst>
+            <a:ext uri="{FF2B5EF4-FFF2-40B4-BE49-F238E27FC236}">
+              <a16:creationId xmlns:a16="http://schemas.microsoft.com/office/drawing/2014/main" id="{B4A7D32C-CF21-5DF8-000E-B7A8A7ADD15D}"/>
+            </a:ext>
+          </a:extLst>
+        </p:cNvPr>
+        <p:cNvGrpSpPr/>
+        <p:nvPr/>
+      </p:nvGrpSpPr>
+      <p:grpSpPr>
+        <a:xfrm>
+          <a:off x="0" y="0"/>
+          <a:ext cx="0" cy="0"/>
+          <a:chOff x="0" y="0"/>
+          <a:chExt cx="0" cy="0"/>
+        </a:xfrm>
+      </p:grpSpPr>
+      <p:sp>
+        <p:nvSpPr>
+          <p:cNvPr id="3" name="TextBox 2">
+            <a:extLst>
+              <a:ext uri="{FF2B5EF4-FFF2-40B4-BE49-F238E27FC236}">
+                <a16:creationId xmlns:a16="http://schemas.microsoft.com/office/drawing/2014/main" id="{F900B2EA-D5DA-630B-87D5-1DEF11433B7F}"/>
+              </a:ext>
+            </a:extLst>
+          </p:cNvPr>
+          <p:cNvSpPr txBox="1"/>
+          <p:nvPr/>
+        </p:nvSpPr>
+        <p:spPr>
+          <a:xfrm>
+            <a:off x="0" y="0"/>
+            <a:ext cx="12192000" cy="355354"/>
+          </a:xfrm>
+          <a:prstGeom prst="rect">
+            <a:avLst/>
+          </a:prstGeom>
+          <a:noFill/>
+        </p:spPr>
+        <p:txBody>
+          <a:bodyPr wrap="square">
+            <a:spAutoFit/>
+          </a:bodyPr>
+          <a:lstStyle/>
+          <a:p>
+            <a:pPr>
+              <a:lnSpc>
+                <a:spcPct val="150000"/>
+              </a:lnSpc>
+              <a:buNone/>
+            </a:pPr>
+            <a:r>
+              <a:rPr kumimoji="0" lang="en-US" altLang="en-US" sz="1300" b="0" i="0" u="none" strike="noStrike" cap="none" normalizeH="0" baseline="0">
+                <a:ln>
+                  <a:noFill/>
+                </a:ln>
+                <a:solidFill>
+                  <a:schemeClr val="tx1"/>
+                </a:solidFill>
+                <a:effectLst/>
+                <a:latin typeface="Arial" panose="020B0604020202020204" pitchFamily="34" charset="0"/>
+              </a:rPr>
+              <a:t>.</a:t>
+            </a:r>
+          </a:p>
+        </p:txBody>
+      </p:sp>
+      <p:pic>
+        <p:nvPicPr>
+          <p:cNvPr id="4" name="Picture 3">
+            <a:extLst>
+              <a:ext uri="{FF2B5EF4-FFF2-40B4-BE49-F238E27FC236}">
+                <a16:creationId xmlns:a16="http://schemas.microsoft.com/office/drawing/2014/main" id="{2E42080B-F7C4-3438-6B44-1581E8BC9968}"/>
+              </a:ext>
+            </a:extLst>
+          </p:cNvPr>
+          <p:cNvPicPr>
+            <a:picLocks noChangeAspect="1"/>
+          </p:cNvPicPr>
+          <p:nvPr/>
+        </p:nvPicPr>
+        <p:blipFill>
+          <a:blip r:embed="rId2"/>
+          <a:stretch>
+            <a:fillRect/>
+          </a:stretch>
+        </p:blipFill>
+        <p:spPr>
+          <a:xfrm>
+            <a:off x="2111795" y="0"/>
+            <a:ext cx="7968409" cy="6858000"/>
+          </a:xfrm>
+          <a:prstGeom prst="rect">
+            <a:avLst/>
+          </a:prstGeom>
+        </p:spPr>
+      </p:pic>
+    </p:spTree>
+    <p:extLst>
+      <p:ext uri="{BB962C8B-B14F-4D97-AF65-F5344CB8AC3E}">
+        <p14:creationId xmlns:p14="http://schemas.microsoft.com/office/powerpoint/2010/main" val="114963407"/>
+      </p:ext>
+    </p:extLst>
+  </p:cSld>
+  <p:clrMapOvr>
+    <a:masterClrMapping/>
+  </p:clrMapOvr>
+</p:sld>
+</file>
+
+<file path=ppt/slides/slide19.xml><?xml version="1.0" encoding="utf-8"?>
+<p:sld xmlns:a="http://schemas.openxmlformats.org/drawingml/2006/main" xmlns:r="http://schemas.openxmlformats.org/officeDocument/2006/relationships" xmlns:p="http://schemas.openxmlformats.org/presentationml/2006/main">
+  <p:cSld>
+    <p:spTree>
+      <p:nvGrpSpPr>
+        <p:cNvPr id="1" name="">
+          <a:extLst>
+            <a:ext uri="{FF2B5EF4-FFF2-40B4-BE49-F238E27FC236}">
+              <a16:creationId xmlns:a16="http://schemas.microsoft.com/office/drawing/2014/main" id="{AB43BC4B-7B85-2AF8-08DB-A1EEA23498A3}"/>
+            </a:ext>
+          </a:extLst>
+        </p:cNvPr>
+        <p:cNvGrpSpPr/>
+        <p:nvPr/>
+      </p:nvGrpSpPr>
+      <p:grpSpPr>
+        <a:xfrm>
+          <a:off x="0" y="0"/>
+          <a:ext cx="0" cy="0"/>
+          <a:chOff x="0" y="0"/>
+          <a:chExt cx="0" cy="0"/>
+        </a:xfrm>
+      </p:grpSpPr>
+      <p:sp>
+        <p:nvSpPr>
+          <p:cNvPr id="3" name="TextBox 2">
+            <a:extLst>
+              <a:ext uri="{FF2B5EF4-FFF2-40B4-BE49-F238E27FC236}">
+                <a16:creationId xmlns:a16="http://schemas.microsoft.com/office/drawing/2014/main" id="{569B7501-FD08-7EA9-86D7-23DDA26D8036}"/>
+              </a:ext>
+            </a:extLst>
+          </p:cNvPr>
+          <p:cNvSpPr txBox="1"/>
+          <p:nvPr/>
+        </p:nvSpPr>
+        <p:spPr>
+          <a:xfrm>
+            <a:off x="0" y="0"/>
+            <a:ext cx="12192000" cy="355354"/>
+          </a:xfrm>
+          <a:prstGeom prst="rect">
+            <a:avLst/>
+          </a:prstGeom>
+          <a:noFill/>
+        </p:spPr>
+        <p:txBody>
+          <a:bodyPr wrap="square">
+            <a:spAutoFit/>
+          </a:bodyPr>
+          <a:lstStyle/>
+          <a:p>
+            <a:pPr>
+              <a:lnSpc>
+                <a:spcPct val="150000"/>
+              </a:lnSpc>
+              <a:buNone/>
+            </a:pPr>
+            <a:r>
+              <a:rPr kumimoji="0" lang="en-US" altLang="en-US" sz="1300" b="0" i="0" u="none" strike="noStrike" cap="none" normalizeH="0" baseline="0">
+                <a:ln>
+                  <a:noFill/>
+                </a:ln>
+                <a:solidFill>
+                  <a:schemeClr val="tx1"/>
+                </a:solidFill>
+                <a:effectLst/>
+                <a:latin typeface="Arial" panose="020B0604020202020204" pitchFamily="34" charset="0"/>
+              </a:rPr>
+              <a:t>.</a:t>
+            </a:r>
+          </a:p>
+        </p:txBody>
+      </p:sp>
+      <p:pic>
+        <p:nvPicPr>
+          <p:cNvPr id="4" name="Picture 3">
+            <a:extLst>
+              <a:ext uri="{FF2B5EF4-FFF2-40B4-BE49-F238E27FC236}">
+                <a16:creationId xmlns:a16="http://schemas.microsoft.com/office/drawing/2014/main" id="{E9B7EB63-5CFB-5271-6347-22B2B36F419B}"/>
+              </a:ext>
+            </a:extLst>
+          </p:cNvPr>
+          <p:cNvPicPr>
+            <a:picLocks noChangeAspect="1"/>
+          </p:cNvPicPr>
+          <p:nvPr/>
+        </p:nvPicPr>
+        <p:blipFill>
+          <a:blip r:embed="rId2"/>
+          <a:stretch>
+            <a:fillRect/>
+          </a:stretch>
+        </p:blipFill>
+        <p:spPr>
+          <a:xfrm>
+            <a:off x="2698620" y="0"/>
+            <a:ext cx="6794760" cy="6858000"/>
+          </a:xfrm>
+          <a:prstGeom prst="rect">
+            <a:avLst/>
+          </a:prstGeom>
+        </p:spPr>
+      </p:pic>
+    </p:spTree>
+    <p:extLst>
+      <p:ext uri="{BB962C8B-B14F-4D97-AF65-F5344CB8AC3E}">
+        <p14:creationId xmlns:p14="http://schemas.microsoft.com/office/powerpoint/2010/main" val="3659118729"/>
       </p:ext>
     </p:extLst>
   </p:cSld>
@@ -3472,6 +4804,36 @@
           </a:p>
         </p:txBody>
       </p:sp>
+      <p:pic>
+        <p:nvPicPr>
+          <p:cNvPr id="4" name="Picture 3">
+            <a:extLst>
+              <a:ext uri="{FF2B5EF4-FFF2-40B4-BE49-F238E27FC236}">
+                <a16:creationId xmlns:a16="http://schemas.microsoft.com/office/drawing/2014/main" id="{87CB75D7-CE27-2266-6A0E-CA632E7ED3AD}"/>
+              </a:ext>
+            </a:extLst>
+          </p:cNvPr>
+          <p:cNvPicPr>
+            <a:picLocks noChangeAspect="1"/>
+          </p:cNvPicPr>
+          <p:nvPr/>
+        </p:nvPicPr>
+        <p:blipFill>
+          <a:blip r:embed="rId2"/>
+          <a:stretch>
+            <a:fillRect/>
+          </a:stretch>
+        </p:blipFill>
+        <p:spPr>
+          <a:xfrm>
+            <a:off x="2394357" y="0"/>
+            <a:ext cx="7403285" cy="6858000"/>
+          </a:xfrm>
+          <a:prstGeom prst="rect">
+            <a:avLst/>
+          </a:prstGeom>
+        </p:spPr>
+      </p:pic>
     </p:spTree>
     <p:extLst>
       <p:ext uri="{BB962C8B-B14F-4D97-AF65-F5344CB8AC3E}">
@@ -3485,7 +4847,1137 @@
 </p:sld>
 </file>
 
+<file path=ppt/slides/slide20.xml><?xml version="1.0" encoding="utf-8"?>
+<p:sld xmlns:a="http://schemas.openxmlformats.org/drawingml/2006/main" xmlns:r="http://schemas.openxmlformats.org/officeDocument/2006/relationships" xmlns:p="http://schemas.openxmlformats.org/presentationml/2006/main">
+  <p:cSld>
+    <p:spTree>
+      <p:nvGrpSpPr>
+        <p:cNvPr id="1" name="">
+          <a:extLst>
+            <a:ext uri="{FF2B5EF4-FFF2-40B4-BE49-F238E27FC236}">
+              <a16:creationId xmlns:a16="http://schemas.microsoft.com/office/drawing/2014/main" id="{F62CD0A7-6AF5-5D5D-B77A-BC087C30D435}"/>
+            </a:ext>
+          </a:extLst>
+        </p:cNvPr>
+        <p:cNvGrpSpPr/>
+        <p:nvPr/>
+      </p:nvGrpSpPr>
+      <p:grpSpPr>
+        <a:xfrm>
+          <a:off x="0" y="0"/>
+          <a:ext cx="0" cy="0"/>
+          <a:chOff x="0" y="0"/>
+          <a:chExt cx="0" cy="0"/>
+        </a:xfrm>
+      </p:grpSpPr>
+      <p:sp>
+        <p:nvSpPr>
+          <p:cNvPr id="3" name="TextBox 2">
+            <a:extLst>
+              <a:ext uri="{FF2B5EF4-FFF2-40B4-BE49-F238E27FC236}">
+                <a16:creationId xmlns:a16="http://schemas.microsoft.com/office/drawing/2014/main" id="{2291428A-E97F-D55C-D8DB-2FC76F3C0BF2}"/>
+              </a:ext>
+            </a:extLst>
+          </p:cNvPr>
+          <p:cNvSpPr txBox="1"/>
+          <p:nvPr/>
+        </p:nvSpPr>
+        <p:spPr>
+          <a:xfrm>
+            <a:off x="0" y="0"/>
+            <a:ext cx="12192000" cy="355354"/>
+          </a:xfrm>
+          <a:prstGeom prst="rect">
+            <a:avLst/>
+          </a:prstGeom>
+          <a:noFill/>
+        </p:spPr>
+        <p:txBody>
+          <a:bodyPr wrap="square">
+            <a:spAutoFit/>
+          </a:bodyPr>
+          <a:lstStyle/>
+          <a:p>
+            <a:pPr>
+              <a:lnSpc>
+                <a:spcPct val="150000"/>
+              </a:lnSpc>
+              <a:buNone/>
+            </a:pPr>
+            <a:r>
+              <a:rPr kumimoji="0" lang="en-US" altLang="en-US" sz="1300" b="0" i="0" u="none" strike="noStrike" cap="none" normalizeH="0" baseline="0">
+                <a:ln>
+                  <a:noFill/>
+                </a:ln>
+                <a:solidFill>
+                  <a:schemeClr val="tx1"/>
+                </a:solidFill>
+                <a:effectLst/>
+                <a:latin typeface="Arial" panose="020B0604020202020204" pitchFamily="34" charset="0"/>
+              </a:rPr>
+              <a:t>.</a:t>
+            </a:r>
+          </a:p>
+        </p:txBody>
+      </p:sp>
+      <p:pic>
+        <p:nvPicPr>
+          <p:cNvPr id="4" name="Picture 3">
+            <a:extLst>
+              <a:ext uri="{FF2B5EF4-FFF2-40B4-BE49-F238E27FC236}">
+                <a16:creationId xmlns:a16="http://schemas.microsoft.com/office/drawing/2014/main" id="{FA6F9CEA-2B31-1B5B-C5FC-6CB978366612}"/>
+              </a:ext>
+            </a:extLst>
+          </p:cNvPr>
+          <p:cNvPicPr>
+            <a:picLocks noChangeAspect="1"/>
+          </p:cNvPicPr>
+          <p:nvPr/>
+        </p:nvPicPr>
+        <p:blipFill>
+          <a:blip r:embed="rId2"/>
+          <a:stretch>
+            <a:fillRect/>
+          </a:stretch>
+        </p:blipFill>
+        <p:spPr>
+          <a:xfrm>
+            <a:off x="1057015" y="0"/>
+            <a:ext cx="10077969" cy="6858000"/>
+          </a:xfrm>
+          <a:prstGeom prst="rect">
+            <a:avLst/>
+          </a:prstGeom>
+        </p:spPr>
+      </p:pic>
+    </p:spTree>
+    <p:extLst>
+      <p:ext uri="{BB962C8B-B14F-4D97-AF65-F5344CB8AC3E}">
+        <p14:creationId xmlns:p14="http://schemas.microsoft.com/office/powerpoint/2010/main" val="3145416475"/>
+      </p:ext>
+    </p:extLst>
+  </p:cSld>
+  <p:clrMapOvr>
+    <a:masterClrMapping/>
+  </p:clrMapOvr>
+</p:sld>
+</file>
+
+<file path=ppt/slides/slide21.xml><?xml version="1.0" encoding="utf-8"?>
+<p:sld xmlns:a="http://schemas.openxmlformats.org/drawingml/2006/main" xmlns:r="http://schemas.openxmlformats.org/officeDocument/2006/relationships" xmlns:p="http://schemas.openxmlformats.org/presentationml/2006/main">
+  <p:cSld>
+    <p:spTree>
+      <p:nvGrpSpPr>
+        <p:cNvPr id="1" name="">
+          <a:extLst>
+            <a:ext uri="{FF2B5EF4-FFF2-40B4-BE49-F238E27FC236}">
+              <a16:creationId xmlns:a16="http://schemas.microsoft.com/office/drawing/2014/main" id="{B6C69193-9322-D7F1-A5CA-15B0FE19C36E}"/>
+            </a:ext>
+          </a:extLst>
+        </p:cNvPr>
+        <p:cNvGrpSpPr/>
+        <p:nvPr/>
+      </p:nvGrpSpPr>
+      <p:grpSpPr>
+        <a:xfrm>
+          <a:off x="0" y="0"/>
+          <a:ext cx="0" cy="0"/>
+          <a:chOff x="0" y="0"/>
+          <a:chExt cx="0" cy="0"/>
+        </a:xfrm>
+      </p:grpSpPr>
+      <p:sp>
+        <p:nvSpPr>
+          <p:cNvPr id="3" name="TextBox 2">
+            <a:extLst>
+              <a:ext uri="{FF2B5EF4-FFF2-40B4-BE49-F238E27FC236}">
+                <a16:creationId xmlns:a16="http://schemas.microsoft.com/office/drawing/2014/main" id="{FD941568-30E6-EE23-0CD7-9808768EC53E}"/>
+              </a:ext>
+            </a:extLst>
+          </p:cNvPr>
+          <p:cNvSpPr txBox="1"/>
+          <p:nvPr/>
+        </p:nvSpPr>
+        <p:spPr>
+          <a:xfrm>
+            <a:off x="0" y="0"/>
+            <a:ext cx="12192000" cy="355354"/>
+          </a:xfrm>
+          <a:prstGeom prst="rect">
+            <a:avLst/>
+          </a:prstGeom>
+          <a:noFill/>
+        </p:spPr>
+        <p:txBody>
+          <a:bodyPr wrap="square">
+            <a:spAutoFit/>
+          </a:bodyPr>
+          <a:lstStyle/>
+          <a:p>
+            <a:pPr>
+              <a:lnSpc>
+                <a:spcPct val="150000"/>
+              </a:lnSpc>
+              <a:buNone/>
+            </a:pPr>
+            <a:r>
+              <a:rPr kumimoji="0" lang="en-US" altLang="en-US" sz="1300" b="0" i="0" u="none" strike="noStrike" cap="none" normalizeH="0" baseline="0">
+                <a:ln>
+                  <a:noFill/>
+                </a:ln>
+                <a:solidFill>
+                  <a:schemeClr val="tx1"/>
+                </a:solidFill>
+                <a:effectLst/>
+                <a:latin typeface="Arial" panose="020B0604020202020204" pitchFamily="34" charset="0"/>
+              </a:rPr>
+              <a:t>.</a:t>
+            </a:r>
+          </a:p>
+        </p:txBody>
+      </p:sp>
+      <p:pic>
+        <p:nvPicPr>
+          <p:cNvPr id="4" name="Picture 3">
+            <a:extLst>
+              <a:ext uri="{FF2B5EF4-FFF2-40B4-BE49-F238E27FC236}">
+                <a16:creationId xmlns:a16="http://schemas.microsoft.com/office/drawing/2014/main" id="{81028F27-B524-C3D4-9231-18BD0E2305DF}"/>
+              </a:ext>
+            </a:extLst>
+          </p:cNvPr>
+          <p:cNvPicPr>
+            <a:picLocks noChangeAspect="1"/>
+          </p:cNvPicPr>
+          <p:nvPr/>
+        </p:nvPicPr>
+        <p:blipFill>
+          <a:blip r:embed="rId2"/>
+          <a:stretch>
+            <a:fillRect/>
+          </a:stretch>
+        </p:blipFill>
+        <p:spPr>
+          <a:xfrm>
+            <a:off x="0" y="579483"/>
+            <a:ext cx="12192000" cy="5699033"/>
+          </a:xfrm>
+          <a:prstGeom prst="rect">
+            <a:avLst/>
+          </a:prstGeom>
+        </p:spPr>
+      </p:pic>
+    </p:spTree>
+    <p:extLst>
+      <p:ext uri="{BB962C8B-B14F-4D97-AF65-F5344CB8AC3E}">
+        <p14:creationId xmlns:p14="http://schemas.microsoft.com/office/powerpoint/2010/main" val="860958322"/>
+      </p:ext>
+    </p:extLst>
+  </p:cSld>
+  <p:clrMapOvr>
+    <a:masterClrMapping/>
+  </p:clrMapOvr>
+</p:sld>
+</file>
+
+<file path=ppt/slides/slide22.xml><?xml version="1.0" encoding="utf-8"?>
+<p:sld xmlns:a="http://schemas.openxmlformats.org/drawingml/2006/main" xmlns:r="http://schemas.openxmlformats.org/officeDocument/2006/relationships" xmlns:p="http://schemas.openxmlformats.org/presentationml/2006/main">
+  <p:cSld>
+    <p:spTree>
+      <p:nvGrpSpPr>
+        <p:cNvPr id="1" name="">
+          <a:extLst>
+            <a:ext uri="{FF2B5EF4-FFF2-40B4-BE49-F238E27FC236}">
+              <a16:creationId xmlns:a16="http://schemas.microsoft.com/office/drawing/2014/main" id="{FA4EDA53-BE45-E2B7-3069-3405D623121C}"/>
+            </a:ext>
+          </a:extLst>
+        </p:cNvPr>
+        <p:cNvGrpSpPr/>
+        <p:nvPr/>
+      </p:nvGrpSpPr>
+      <p:grpSpPr>
+        <a:xfrm>
+          <a:off x="0" y="0"/>
+          <a:ext cx="0" cy="0"/>
+          <a:chOff x="0" y="0"/>
+          <a:chExt cx="0" cy="0"/>
+        </a:xfrm>
+      </p:grpSpPr>
+      <p:sp>
+        <p:nvSpPr>
+          <p:cNvPr id="3" name="TextBox 2">
+            <a:extLst>
+              <a:ext uri="{FF2B5EF4-FFF2-40B4-BE49-F238E27FC236}">
+                <a16:creationId xmlns:a16="http://schemas.microsoft.com/office/drawing/2014/main" id="{917C9413-36C7-7EDB-8576-9F3CBE878C13}"/>
+              </a:ext>
+            </a:extLst>
+          </p:cNvPr>
+          <p:cNvSpPr txBox="1"/>
+          <p:nvPr/>
+        </p:nvSpPr>
+        <p:spPr>
+          <a:xfrm>
+            <a:off x="0" y="0"/>
+            <a:ext cx="12192000" cy="355354"/>
+          </a:xfrm>
+          <a:prstGeom prst="rect">
+            <a:avLst/>
+          </a:prstGeom>
+          <a:noFill/>
+        </p:spPr>
+        <p:txBody>
+          <a:bodyPr wrap="square">
+            <a:spAutoFit/>
+          </a:bodyPr>
+          <a:lstStyle/>
+          <a:p>
+            <a:pPr>
+              <a:lnSpc>
+                <a:spcPct val="150000"/>
+              </a:lnSpc>
+              <a:buNone/>
+            </a:pPr>
+            <a:r>
+              <a:rPr kumimoji="0" lang="en-US" altLang="en-US" sz="1300" b="0" i="0" u="none" strike="noStrike" cap="none" normalizeH="0" baseline="0">
+                <a:ln>
+                  <a:noFill/>
+                </a:ln>
+                <a:solidFill>
+                  <a:schemeClr val="tx1"/>
+                </a:solidFill>
+                <a:effectLst/>
+                <a:latin typeface="Arial" panose="020B0604020202020204" pitchFamily="34" charset="0"/>
+              </a:rPr>
+              <a:t>.</a:t>
+            </a:r>
+          </a:p>
+        </p:txBody>
+      </p:sp>
+      <p:pic>
+        <p:nvPicPr>
+          <p:cNvPr id="4" name="Picture 3">
+            <a:extLst>
+              <a:ext uri="{FF2B5EF4-FFF2-40B4-BE49-F238E27FC236}">
+                <a16:creationId xmlns:a16="http://schemas.microsoft.com/office/drawing/2014/main" id="{E8278705-E010-F352-E1D4-C0B40E1FD3AE}"/>
+              </a:ext>
+            </a:extLst>
+          </p:cNvPr>
+          <p:cNvPicPr>
+            <a:picLocks noChangeAspect="1"/>
+          </p:cNvPicPr>
+          <p:nvPr/>
+        </p:nvPicPr>
+        <p:blipFill>
+          <a:blip r:embed="rId2"/>
+          <a:stretch>
+            <a:fillRect/>
+          </a:stretch>
+        </p:blipFill>
+        <p:spPr>
+          <a:xfrm>
+            <a:off x="0" y="1901818"/>
+            <a:ext cx="12192000" cy="3054363"/>
+          </a:xfrm>
+          <a:prstGeom prst="rect">
+            <a:avLst/>
+          </a:prstGeom>
+          <a:solidFill>
+            <a:srgbClr val="FFFFFF">
+              <a:shade val="85000"/>
+            </a:srgbClr>
+          </a:solidFill>
+          <a:ln w="88900" cap="sq">
+            <a:solidFill>
+              <a:srgbClr val="FFFFFF"/>
+            </a:solidFill>
+            <a:miter lim="800000"/>
+          </a:ln>
+          <a:effectLst>
+            <a:outerShdw blurRad="55000" dist="18000" dir="5400000" algn="tl" rotWithShape="0">
+              <a:srgbClr val="000000">
+                <a:alpha val="40000"/>
+              </a:srgbClr>
+            </a:outerShdw>
+          </a:effectLst>
+          <a:scene3d>
+            <a:camera prst="orthographicFront"/>
+            <a:lightRig rig="twoPt" dir="t">
+              <a:rot lat="0" lon="0" rev="7200000"/>
+            </a:lightRig>
+          </a:scene3d>
+          <a:sp3d>
+            <a:bevelT w="25400" h="19050"/>
+            <a:contourClr>
+              <a:srgbClr val="FFFFFF"/>
+            </a:contourClr>
+          </a:sp3d>
+        </p:spPr>
+      </p:pic>
+    </p:spTree>
+    <p:extLst>
+      <p:ext uri="{BB962C8B-B14F-4D97-AF65-F5344CB8AC3E}">
+        <p14:creationId xmlns:p14="http://schemas.microsoft.com/office/powerpoint/2010/main" val="3376092710"/>
+      </p:ext>
+    </p:extLst>
+  </p:cSld>
+  <p:clrMapOvr>
+    <a:masterClrMapping/>
+  </p:clrMapOvr>
+</p:sld>
+</file>
+
+<file path=ppt/slides/slide23.xml><?xml version="1.0" encoding="utf-8"?>
+<p:sld xmlns:a="http://schemas.openxmlformats.org/drawingml/2006/main" xmlns:r="http://schemas.openxmlformats.org/officeDocument/2006/relationships" xmlns:p="http://schemas.openxmlformats.org/presentationml/2006/main">
+  <p:cSld>
+    <p:spTree>
+      <p:nvGrpSpPr>
+        <p:cNvPr id="1" name="">
+          <a:extLst>
+            <a:ext uri="{FF2B5EF4-FFF2-40B4-BE49-F238E27FC236}">
+              <a16:creationId xmlns:a16="http://schemas.microsoft.com/office/drawing/2014/main" id="{A8F3E3B1-6EBD-B494-8725-C6D72E41EEE5}"/>
+            </a:ext>
+          </a:extLst>
+        </p:cNvPr>
+        <p:cNvGrpSpPr/>
+        <p:nvPr/>
+      </p:nvGrpSpPr>
+      <p:grpSpPr>
+        <a:xfrm>
+          <a:off x="0" y="0"/>
+          <a:ext cx="0" cy="0"/>
+          <a:chOff x="0" y="0"/>
+          <a:chExt cx="0" cy="0"/>
+        </a:xfrm>
+      </p:grpSpPr>
+      <p:sp>
+        <p:nvSpPr>
+          <p:cNvPr id="3" name="TextBox 2">
+            <a:extLst>
+              <a:ext uri="{FF2B5EF4-FFF2-40B4-BE49-F238E27FC236}">
+                <a16:creationId xmlns:a16="http://schemas.microsoft.com/office/drawing/2014/main" id="{163A8524-3B7B-6233-2F82-850D560A08C5}"/>
+              </a:ext>
+            </a:extLst>
+          </p:cNvPr>
+          <p:cNvSpPr txBox="1"/>
+          <p:nvPr/>
+        </p:nvSpPr>
+        <p:spPr>
+          <a:xfrm>
+            <a:off x="0" y="0"/>
+            <a:ext cx="12192000" cy="355354"/>
+          </a:xfrm>
+          <a:prstGeom prst="rect">
+            <a:avLst/>
+          </a:prstGeom>
+          <a:noFill/>
+        </p:spPr>
+        <p:txBody>
+          <a:bodyPr wrap="square">
+            <a:spAutoFit/>
+          </a:bodyPr>
+          <a:lstStyle/>
+          <a:p>
+            <a:pPr>
+              <a:lnSpc>
+                <a:spcPct val="150000"/>
+              </a:lnSpc>
+              <a:buNone/>
+            </a:pPr>
+            <a:r>
+              <a:rPr kumimoji="0" lang="en-US" altLang="en-US" sz="1300" b="0" i="0" u="none" strike="noStrike" cap="none" normalizeH="0" baseline="0">
+                <a:ln>
+                  <a:noFill/>
+                </a:ln>
+                <a:solidFill>
+                  <a:schemeClr val="tx1"/>
+                </a:solidFill>
+                <a:effectLst/>
+                <a:latin typeface="Arial" panose="020B0604020202020204" pitchFamily="34" charset="0"/>
+              </a:rPr>
+              <a:t>.</a:t>
+            </a:r>
+          </a:p>
+        </p:txBody>
+      </p:sp>
+      <p:pic>
+        <p:nvPicPr>
+          <p:cNvPr id="4" name="Picture 3">
+            <a:extLst>
+              <a:ext uri="{FF2B5EF4-FFF2-40B4-BE49-F238E27FC236}">
+                <a16:creationId xmlns:a16="http://schemas.microsoft.com/office/drawing/2014/main" id="{A00AF705-3C98-A827-C19A-44520CE9D2AA}"/>
+              </a:ext>
+            </a:extLst>
+          </p:cNvPr>
+          <p:cNvPicPr>
+            <a:picLocks noChangeAspect="1"/>
+          </p:cNvPicPr>
+          <p:nvPr/>
+        </p:nvPicPr>
+        <p:blipFill>
+          <a:blip r:embed="rId2"/>
+          <a:stretch>
+            <a:fillRect/>
+          </a:stretch>
+        </p:blipFill>
+        <p:spPr>
+          <a:xfrm>
+            <a:off x="2408075" y="0"/>
+            <a:ext cx="7375849" cy="6858000"/>
+          </a:xfrm>
+          <a:prstGeom prst="rect">
+            <a:avLst/>
+          </a:prstGeom>
+        </p:spPr>
+      </p:pic>
+    </p:spTree>
+    <p:extLst>
+      <p:ext uri="{BB962C8B-B14F-4D97-AF65-F5344CB8AC3E}">
+        <p14:creationId xmlns:p14="http://schemas.microsoft.com/office/powerpoint/2010/main" val="552963235"/>
+      </p:ext>
+    </p:extLst>
+  </p:cSld>
+  <p:clrMapOvr>
+    <a:masterClrMapping/>
+  </p:clrMapOvr>
+</p:sld>
+</file>
+
+<file path=ppt/slides/slide24.xml><?xml version="1.0" encoding="utf-8"?>
+<p:sld xmlns:a="http://schemas.openxmlformats.org/drawingml/2006/main" xmlns:r="http://schemas.openxmlformats.org/officeDocument/2006/relationships" xmlns:p="http://schemas.openxmlformats.org/presentationml/2006/main">
+  <p:cSld>
+    <p:spTree>
+      <p:nvGrpSpPr>
+        <p:cNvPr id="1" name="">
+          <a:extLst>
+            <a:ext uri="{FF2B5EF4-FFF2-40B4-BE49-F238E27FC236}">
+              <a16:creationId xmlns:a16="http://schemas.microsoft.com/office/drawing/2014/main" id="{BD967A58-B252-503F-7645-D7062F05C998}"/>
+            </a:ext>
+          </a:extLst>
+        </p:cNvPr>
+        <p:cNvGrpSpPr/>
+        <p:nvPr/>
+      </p:nvGrpSpPr>
+      <p:grpSpPr>
+        <a:xfrm>
+          <a:off x="0" y="0"/>
+          <a:ext cx="0" cy="0"/>
+          <a:chOff x="0" y="0"/>
+          <a:chExt cx="0" cy="0"/>
+        </a:xfrm>
+      </p:grpSpPr>
+      <p:sp>
+        <p:nvSpPr>
+          <p:cNvPr id="3" name="TextBox 2">
+            <a:extLst>
+              <a:ext uri="{FF2B5EF4-FFF2-40B4-BE49-F238E27FC236}">
+                <a16:creationId xmlns:a16="http://schemas.microsoft.com/office/drawing/2014/main" id="{5D5D9AD7-FB17-8F28-545E-6267D11ECE01}"/>
+              </a:ext>
+            </a:extLst>
+          </p:cNvPr>
+          <p:cNvSpPr txBox="1"/>
+          <p:nvPr/>
+        </p:nvSpPr>
+        <p:spPr>
+          <a:xfrm>
+            <a:off x="0" y="0"/>
+            <a:ext cx="12192000" cy="355354"/>
+          </a:xfrm>
+          <a:prstGeom prst="rect">
+            <a:avLst/>
+          </a:prstGeom>
+          <a:noFill/>
+        </p:spPr>
+        <p:txBody>
+          <a:bodyPr wrap="square">
+            <a:spAutoFit/>
+          </a:bodyPr>
+          <a:lstStyle/>
+          <a:p>
+            <a:pPr>
+              <a:lnSpc>
+                <a:spcPct val="150000"/>
+              </a:lnSpc>
+              <a:buNone/>
+            </a:pPr>
+            <a:r>
+              <a:rPr kumimoji="0" lang="en-US" altLang="en-US" sz="1300" b="0" i="0" u="none" strike="noStrike" cap="none" normalizeH="0" baseline="0">
+                <a:ln>
+                  <a:noFill/>
+                </a:ln>
+                <a:solidFill>
+                  <a:schemeClr val="tx1"/>
+                </a:solidFill>
+                <a:effectLst/>
+                <a:latin typeface="Arial" panose="020B0604020202020204" pitchFamily="34" charset="0"/>
+              </a:rPr>
+              <a:t>.</a:t>
+            </a:r>
+          </a:p>
+        </p:txBody>
+      </p:sp>
+      <p:pic>
+        <p:nvPicPr>
+          <p:cNvPr id="8" name="Picture 7">
+            <a:extLst>
+              <a:ext uri="{FF2B5EF4-FFF2-40B4-BE49-F238E27FC236}">
+                <a16:creationId xmlns:a16="http://schemas.microsoft.com/office/drawing/2014/main" id="{0E1F20B9-A767-44A4-C216-6F1CC9E1FDF3}"/>
+              </a:ext>
+            </a:extLst>
+          </p:cNvPr>
+          <p:cNvPicPr>
+            <a:picLocks noChangeAspect="1"/>
+          </p:cNvPicPr>
+          <p:nvPr/>
+        </p:nvPicPr>
+        <p:blipFill>
+          <a:blip r:embed="rId2"/>
+          <a:stretch>
+            <a:fillRect/>
+          </a:stretch>
+        </p:blipFill>
+        <p:spPr>
+          <a:xfrm>
+            <a:off x="2041296" y="0"/>
+            <a:ext cx="8109408" cy="6858000"/>
+          </a:xfrm>
+          <a:prstGeom prst="rect">
+            <a:avLst/>
+          </a:prstGeom>
+        </p:spPr>
+      </p:pic>
+    </p:spTree>
+    <p:extLst>
+      <p:ext uri="{BB962C8B-B14F-4D97-AF65-F5344CB8AC3E}">
+        <p14:creationId xmlns:p14="http://schemas.microsoft.com/office/powerpoint/2010/main" val="3325258124"/>
+      </p:ext>
+    </p:extLst>
+  </p:cSld>
+  <p:clrMapOvr>
+    <a:masterClrMapping/>
+  </p:clrMapOvr>
+</p:sld>
+</file>
+
+<file path=ppt/slides/slide25.xml><?xml version="1.0" encoding="utf-8"?>
+<p:sld xmlns:a="http://schemas.openxmlformats.org/drawingml/2006/main" xmlns:r="http://schemas.openxmlformats.org/officeDocument/2006/relationships" xmlns:p="http://schemas.openxmlformats.org/presentationml/2006/main">
+  <p:cSld>
+    <p:spTree>
+      <p:nvGrpSpPr>
+        <p:cNvPr id="1" name="">
+          <a:extLst>
+            <a:ext uri="{FF2B5EF4-FFF2-40B4-BE49-F238E27FC236}">
+              <a16:creationId xmlns:a16="http://schemas.microsoft.com/office/drawing/2014/main" id="{234FC578-E916-157D-9E34-98C92603E544}"/>
+            </a:ext>
+          </a:extLst>
+        </p:cNvPr>
+        <p:cNvGrpSpPr/>
+        <p:nvPr/>
+      </p:nvGrpSpPr>
+      <p:grpSpPr>
+        <a:xfrm>
+          <a:off x="0" y="0"/>
+          <a:ext cx="0" cy="0"/>
+          <a:chOff x="0" y="0"/>
+          <a:chExt cx="0" cy="0"/>
+        </a:xfrm>
+      </p:grpSpPr>
+      <p:sp>
+        <p:nvSpPr>
+          <p:cNvPr id="3" name="TextBox 2">
+            <a:extLst>
+              <a:ext uri="{FF2B5EF4-FFF2-40B4-BE49-F238E27FC236}">
+                <a16:creationId xmlns:a16="http://schemas.microsoft.com/office/drawing/2014/main" id="{44E910EB-F8CF-72DB-1654-E9E111A3D87E}"/>
+              </a:ext>
+            </a:extLst>
+          </p:cNvPr>
+          <p:cNvSpPr txBox="1"/>
+          <p:nvPr/>
+        </p:nvSpPr>
+        <p:spPr>
+          <a:xfrm>
+            <a:off x="0" y="0"/>
+            <a:ext cx="12192000" cy="355354"/>
+          </a:xfrm>
+          <a:prstGeom prst="rect">
+            <a:avLst/>
+          </a:prstGeom>
+          <a:noFill/>
+        </p:spPr>
+        <p:txBody>
+          <a:bodyPr wrap="square">
+            <a:spAutoFit/>
+          </a:bodyPr>
+          <a:lstStyle/>
+          <a:p>
+            <a:pPr>
+              <a:lnSpc>
+                <a:spcPct val="150000"/>
+              </a:lnSpc>
+              <a:buNone/>
+            </a:pPr>
+            <a:r>
+              <a:rPr kumimoji="0" lang="en-US" altLang="en-US" sz="1300" b="0" i="0" u="none" strike="noStrike" cap="none" normalizeH="0" baseline="0">
+                <a:ln>
+                  <a:noFill/>
+                </a:ln>
+                <a:solidFill>
+                  <a:schemeClr val="tx1"/>
+                </a:solidFill>
+                <a:effectLst/>
+                <a:latin typeface="Arial" panose="020B0604020202020204" pitchFamily="34" charset="0"/>
+              </a:rPr>
+              <a:t>.</a:t>
+            </a:r>
+          </a:p>
+        </p:txBody>
+      </p:sp>
+      <p:pic>
+        <p:nvPicPr>
+          <p:cNvPr id="4" name="Picture 3">
+            <a:extLst>
+              <a:ext uri="{FF2B5EF4-FFF2-40B4-BE49-F238E27FC236}">
+                <a16:creationId xmlns:a16="http://schemas.microsoft.com/office/drawing/2014/main" id="{8287EF9E-A0A9-952D-533E-816C44B1FDD8}"/>
+              </a:ext>
+            </a:extLst>
+          </p:cNvPr>
+          <p:cNvPicPr>
+            <a:picLocks noChangeAspect="1"/>
+          </p:cNvPicPr>
+          <p:nvPr/>
+        </p:nvPicPr>
+        <p:blipFill>
+          <a:blip r:embed="rId2"/>
+          <a:stretch>
+            <a:fillRect/>
+          </a:stretch>
+        </p:blipFill>
+        <p:spPr>
+          <a:xfrm>
+            <a:off x="446381" y="0"/>
+            <a:ext cx="11299237" cy="6858000"/>
+          </a:xfrm>
+          <a:prstGeom prst="rect">
+            <a:avLst/>
+          </a:prstGeom>
+        </p:spPr>
+      </p:pic>
+    </p:spTree>
+    <p:extLst>
+      <p:ext uri="{BB962C8B-B14F-4D97-AF65-F5344CB8AC3E}">
+        <p14:creationId xmlns:p14="http://schemas.microsoft.com/office/powerpoint/2010/main" val="616314994"/>
+      </p:ext>
+    </p:extLst>
+  </p:cSld>
+  <p:clrMapOvr>
+    <a:masterClrMapping/>
+  </p:clrMapOvr>
+</p:sld>
+</file>
+
+<file path=ppt/slides/slide26.xml><?xml version="1.0" encoding="utf-8"?>
+<p:sld xmlns:a="http://schemas.openxmlformats.org/drawingml/2006/main" xmlns:r="http://schemas.openxmlformats.org/officeDocument/2006/relationships" xmlns:p="http://schemas.openxmlformats.org/presentationml/2006/main">
+  <p:cSld>
+    <p:spTree>
+      <p:nvGrpSpPr>
+        <p:cNvPr id="1" name="">
+          <a:extLst>
+            <a:ext uri="{FF2B5EF4-FFF2-40B4-BE49-F238E27FC236}">
+              <a16:creationId xmlns:a16="http://schemas.microsoft.com/office/drawing/2014/main" id="{C46ADA9B-CF14-1B7E-F3E8-2B1FC74BCE2B}"/>
+            </a:ext>
+          </a:extLst>
+        </p:cNvPr>
+        <p:cNvGrpSpPr/>
+        <p:nvPr/>
+      </p:nvGrpSpPr>
+      <p:grpSpPr>
+        <a:xfrm>
+          <a:off x="0" y="0"/>
+          <a:ext cx="0" cy="0"/>
+          <a:chOff x="0" y="0"/>
+          <a:chExt cx="0" cy="0"/>
+        </a:xfrm>
+      </p:grpSpPr>
+      <p:sp>
+        <p:nvSpPr>
+          <p:cNvPr id="3" name="TextBox 2">
+            <a:extLst>
+              <a:ext uri="{FF2B5EF4-FFF2-40B4-BE49-F238E27FC236}">
+                <a16:creationId xmlns:a16="http://schemas.microsoft.com/office/drawing/2014/main" id="{8EDEA50B-0669-BC50-EECD-FECF4C750807}"/>
+              </a:ext>
+            </a:extLst>
+          </p:cNvPr>
+          <p:cNvSpPr txBox="1"/>
+          <p:nvPr/>
+        </p:nvSpPr>
+        <p:spPr>
+          <a:xfrm>
+            <a:off x="0" y="0"/>
+            <a:ext cx="12192000" cy="355354"/>
+          </a:xfrm>
+          <a:prstGeom prst="rect">
+            <a:avLst/>
+          </a:prstGeom>
+          <a:noFill/>
+        </p:spPr>
+        <p:txBody>
+          <a:bodyPr wrap="square">
+            <a:spAutoFit/>
+          </a:bodyPr>
+          <a:lstStyle/>
+          <a:p>
+            <a:pPr>
+              <a:lnSpc>
+                <a:spcPct val="150000"/>
+              </a:lnSpc>
+              <a:buNone/>
+            </a:pPr>
+            <a:r>
+              <a:rPr kumimoji="0" lang="en-US" altLang="en-US" sz="1300" b="0" i="0" u="none" strike="noStrike" cap="none" normalizeH="0" baseline="0">
+                <a:ln>
+                  <a:noFill/>
+                </a:ln>
+                <a:solidFill>
+                  <a:schemeClr val="tx1"/>
+                </a:solidFill>
+                <a:effectLst/>
+                <a:latin typeface="Arial" panose="020B0604020202020204" pitchFamily="34" charset="0"/>
+              </a:rPr>
+              <a:t>.</a:t>
+            </a:r>
+          </a:p>
+        </p:txBody>
+      </p:sp>
+    </p:spTree>
+    <p:extLst>
+      <p:ext uri="{BB962C8B-B14F-4D97-AF65-F5344CB8AC3E}">
+        <p14:creationId xmlns:p14="http://schemas.microsoft.com/office/powerpoint/2010/main" val="260984054"/>
+      </p:ext>
+    </p:extLst>
+  </p:cSld>
+  <p:clrMapOvr>
+    <a:masterClrMapping/>
+  </p:clrMapOvr>
+</p:sld>
+</file>
+
+<file path=ppt/slides/slide27.xml><?xml version="1.0" encoding="utf-8"?>
+<p:sld xmlns:a="http://schemas.openxmlformats.org/drawingml/2006/main" xmlns:r="http://schemas.openxmlformats.org/officeDocument/2006/relationships" xmlns:p="http://schemas.openxmlformats.org/presentationml/2006/main">
+  <p:cSld>
+    <p:spTree>
+      <p:nvGrpSpPr>
+        <p:cNvPr id="1" name="">
+          <a:extLst>
+            <a:ext uri="{FF2B5EF4-FFF2-40B4-BE49-F238E27FC236}">
+              <a16:creationId xmlns:a16="http://schemas.microsoft.com/office/drawing/2014/main" id="{1D559C01-B1BE-7DE3-FECE-8DE232127E8C}"/>
+            </a:ext>
+          </a:extLst>
+        </p:cNvPr>
+        <p:cNvGrpSpPr/>
+        <p:nvPr/>
+      </p:nvGrpSpPr>
+      <p:grpSpPr>
+        <a:xfrm>
+          <a:off x="0" y="0"/>
+          <a:ext cx="0" cy="0"/>
+          <a:chOff x="0" y="0"/>
+          <a:chExt cx="0" cy="0"/>
+        </a:xfrm>
+      </p:grpSpPr>
+      <p:sp>
+        <p:nvSpPr>
+          <p:cNvPr id="3" name="TextBox 2">
+            <a:extLst>
+              <a:ext uri="{FF2B5EF4-FFF2-40B4-BE49-F238E27FC236}">
+                <a16:creationId xmlns:a16="http://schemas.microsoft.com/office/drawing/2014/main" id="{D497E22F-6576-E49B-3EC6-EF697DF249DB}"/>
+              </a:ext>
+            </a:extLst>
+          </p:cNvPr>
+          <p:cNvSpPr txBox="1"/>
+          <p:nvPr/>
+        </p:nvSpPr>
+        <p:spPr>
+          <a:xfrm>
+            <a:off x="0" y="0"/>
+            <a:ext cx="12192000" cy="355354"/>
+          </a:xfrm>
+          <a:prstGeom prst="rect">
+            <a:avLst/>
+          </a:prstGeom>
+          <a:noFill/>
+        </p:spPr>
+        <p:txBody>
+          <a:bodyPr wrap="square">
+            <a:spAutoFit/>
+          </a:bodyPr>
+          <a:lstStyle/>
+          <a:p>
+            <a:pPr>
+              <a:lnSpc>
+                <a:spcPct val="150000"/>
+              </a:lnSpc>
+              <a:buNone/>
+            </a:pPr>
+            <a:r>
+              <a:rPr kumimoji="0" lang="en-US" altLang="en-US" sz="1300" b="0" i="0" u="none" strike="noStrike" cap="none" normalizeH="0" baseline="0">
+                <a:ln>
+                  <a:noFill/>
+                </a:ln>
+                <a:solidFill>
+                  <a:schemeClr val="tx1"/>
+                </a:solidFill>
+                <a:effectLst/>
+                <a:latin typeface="Arial" panose="020B0604020202020204" pitchFamily="34" charset="0"/>
+              </a:rPr>
+              <a:t>.</a:t>
+            </a:r>
+          </a:p>
+        </p:txBody>
+      </p:sp>
+    </p:spTree>
+    <p:extLst>
+      <p:ext uri="{BB962C8B-B14F-4D97-AF65-F5344CB8AC3E}">
+        <p14:creationId xmlns:p14="http://schemas.microsoft.com/office/powerpoint/2010/main" val="2976204648"/>
+      </p:ext>
+    </p:extLst>
+  </p:cSld>
+  <p:clrMapOvr>
+    <a:masterClrMapping/>
+  </p:clrMapOvr>
+</p:sld>
+</file>
+
 <file path=ppt/slides/slide3.xml><?xml version="1.0" encoding="utf-8"?>
+<p:sld xmlns:a="http://schemas.openxmlformats.org/drawingml/2006/main" xmlns:r="http://schemas.openxmlformats.org/officeDocument/2006/relationships" xmlns:p="http://schemas.openxmlformats.org/presentationml/2006/main">
+  <p:cSld>
+    <p:spTree>
+      <p:nvGrpSpPr>
+        <p:cNvPr id="1" name="">
+          <a:extLst>
+            <a:ext uri="{FF2B5EF4-FFF2-40B4-BE49-F238E27FC236}">
+              <a16:creationId xmlns:a16="http://schemas.microsoft.com/office/drawing/2014/main" id="{1331EEFC-2B95-D974-787D-049534E61A95}"/>
+            </a:ext>
+          </a:extLst>
+        </p:cNvPr>
+        <p:cNvGrpSpPr/>
+        <p:nvPr/>
+      </p:nvGrpSpPr>
+      <p:grpSpPr>
+        <a:xfrm>
+          <a:off x="0" y="0"/>
+          <a:ext cx="0" cy="0"/>
+          <a:chOff x="0" y="0"/>
+          <a:chExt cx="0" cy="0"/>
+        </a:xfrm>
+      </p:grpSpPr>
+      <p:sp>
+        <p:nvSpPr>
+          <p:cNvPr id="3" name="TextBox 2">
+            <a:extLst>
+              <a:ext uri="{FF2B5EF4-FFF2-40B4-BE49-F238E27FC236}">
+                <a16:creationId xmlns:a16="http://schemas.microsoft.com/office/drawing/2014/main" id="{7A167462-24D7-E373-0E0F-28384DEC41EA}"/>
+              </a:ext>
+            </a:extLst>
+          </p:cNvPr>
+          <p:cNvSpPr txBox="1"/>
+          <p:nvPr/>
+        </p:nvSpPr>
+        <p:spPr>
+          <a:xfrm>
+            <a:off x="0" y="0"/>
+            <a:ext cx="12192000" cy="355354"/>
+          </a:xfrm>
+          <a:prstGeom prst="rect">
+            <a:avLst/>
+          </a:prstGeom>
+          <a:noFill/>
+        </p:spPr>
+        <p:txBody>
+          <a:bodyPr wrap="square">
+            <a:spAutoFit/>
+          </a:bodyPr>
+          <a:lstStyle/>
+          <a:p>
+            <a:pPr>
+              <a:lnSpc>
+                <a:spcPct val="150000"/>
+              </a:lnSpc>
+              <a:buNone/>
+            </a:pPr>
+            <a:r>
+              <a:rPr kumimoji="0" lang="en-US" altLang="en-US" sz="1300" b="0" i="0" u="none" strike="noStrike" cap="none" normalizeH="0" baseline="0">
+                <a:ln>
+                  <a:noFill/>
+                </a:ln>
+                <a:solidFill>
+                  <a:schemeClr val="tx1"/>
+                </a:solidFill>
+                <a:effectLst/>
+                <a:latin typeface="Arial" panose="020B0604020202020204" pitchFamily="34" charset="0"/>
+              </a:rPr>
+              <a:t>.</a:t>
+            </a:r>
+          </a:p>
+        </p:txBody>
+      </p:sp>
+      <p:pic>
+        <p:nvPicPr>
+          <p:cNvPr id="4" name="Picture 3">
+            <a:extLst>
+              <a:ext uri="{FF2B5EF4-FFF2-40B4-BE49-F238E27FC236}">
+                <a16:creationId xmlns:a16="http://schemas.microsoft.com/office/drawing/2014/main" id="{F07B7F1A-57F2-1F2A-1E09-3CFE99424FF6}"/>
+              </a:ext>
+            </a:extLst>
+          </p:cNvPr>
+          <p:cNvPicPr>
+            <a:picLocks noChangeAspect="1"/>
+          </p:cNvPicPr>
+          <p:nvPr/>
+        </p:nvPicPr>
+        <p:blipFill>
+          <a:blip r:embed="rId2"/>
+          <a:stretch>
+            <a:fillRect/>
+          </a:stretch>
+        </p:blipFill>
+        <p:spPr>
+          <a:xfrm>
+            <a:off x="1870046" y="0"/>
+            <a:ext cx="8451908" cy="6858000"/>
+          </a:xfrm>
+          <a:prstGeom prst="rect">
+            <a:avLst/>
+          </a:prstGeom>
+        </p:spPr>
+      </p:pic>
+    </p:spTree>
+    <p:extLst>
+      <p:ext uri="{BB962C8B-B14F-4D97-AF65-F5344CB8AC3E}">
+        <p14:creationId xmlns:p14="http://schemas.microsoft.com/office/powerpoint/2010/main" val="3174394980"/>
+      </p:ext>
+    </p:extLst>
+  </p:cSld>
+  <p:clrMapOvr>
+    <a:masterClrMapping/>
+  </p:clrMapOvr>
+</p:sld>
+</file>
+
+<file path=ppt/slides/slide4.xml><?xml version="1.0" encoding="utf-8"?>
+<p:sld xmlns:a="http://schemas.openxmlformats.org/drawingml/2006/main" xmlns:r="http://schemas.openxmlformats.org/officeDocument/2006/relationships" xmlns:p="http://schemas.openxmlformats.org/presentationml/2006/main">
+  <p:cSld>
+    <p:spTree>
+      <p:nvGrpSpPr>
+        <p:cNvPr id="1" name="">
+          <a:extLst>
+            <a:ext uri="{FF2B5EF4-FFF2-40B4-BE49-F238E27FC236}">
+              <a16:creationId xmlns:a16="http://schemas.microsoft.com/office/drawing/2014/main" id="{0BE02F0C-6EEB-EB2D-7A47-6D18CFEA5B13}"/>
+            </a:ext>
+          </a:extLst>
+        </p:cNvPr>
+        <p:cNvGrpSpPr/>
+        <p:nvPr/>
+      </p:nvGrpSpPr>
+      <p:grpSpPr>
+        <a:xfrm>
+          <a:off x="0" y="0"/>
+          <a:ext cx="0" cy="0"/>
+          <a:chOff x="0" y="0"/>
+          <a:chExt cx="0" cy="0"/>
+        </a:xfrm>
+      </p:grpSpPr>
+      <p:sp>
+        <p:nvSpPr>
+          <p:cNvPr id="3" name="TextBox 2">
+            <a:extLst>
+              <a:ext uri="{FF2B5EF4-FFF2-40B4-BE49-F238E27FC236}">
+                <a16:creationId xmlns:a16="http://schemas.microsoft.com/office/drawing/2014/main" id="{95252568-7D85-ED51-14E1-614265BC9406}"/>
+              </a:ext>
+            </a:extLst>
+          </p:cNvPr>
+          <p:cNvSpPr txBox="1"/>
+          <p:nvPr/>
+        </p:nvSpPr>
+        <p:spPr>
+          <a:xfrm>
+            <a:off x="0" y="0"/>
+            <a:ext cx="12192000" cy="355354"/>
+          </a:xfrm>
+          <a:prstGeom prst="rect">
+            <a:avLst/>
+          </a:prstGeom>
+          <a:noFill/>
+        </p:spPr>
+        <p:txBody>
+          <a:bodyPr wrap="square">
+            <a:spAutoFit/>
+          </a:bodyPr>
+          <a:lstStyle/>
+          <a:p>
+            <a:pPr>
+              <a:lnSpc>
+                <a:spcPct val="150000"/>
+              </a:lnSpc>
+              <a:buNone/>
+            </a:pPr>
+            <a:r>
+              <a:rPr kumimoji="0" lang="en-US" altLang="en-US" sz="1300" b="0" i="0" u="none" strike="noStrike" cap="none" normalizeH="0" baseline="0">
+                <a:ln>
+                  <a:noFill/>
+                </a:ln>
+                <a:solidFill>
+                  <a:schemeClr val="tx1"/>
+                </a:solidFill>
+                <a:effectLst/>
+                <a:latin typeface="Arial" panose="020B0604020202020204" pitchFamily="34" charset="0"/>
+              </a:rPr>
+              <a:t>.</a:t>
+            </a:r>
+          </a:p>
+        </p:txBody>
+      </p:sp>
+      <p:pic>
+        <p:nvPicPr>
+          <p:cNvPr id="4" name="Picture 3">
+            <a:extLst>
+              <a:ext uri="{FF2B5EF4-FFF2-40B4-BE49-F238E27FC236}">
+                <a16:creationId xmlns:a16="http://schemas.microsoft.com/office/drawing/2014/main" id="{45B8A3AF-8609-D72A-160E-0395AB039751}"/>
+              </a:ext>
+            </a:extLst>
+          </p:cNvPr>
+          <p:cNvPicPr>
+            <a:picLocks noChangeAspect="1"/>
+          </p:cNvPicPr>
+          <p:nvPr/>
+        </p:nvPicPr>
+        <p:blipFill>
+          <a:blip r:embed="rId2"/>
+          <a:stretch>
+            <a:fillRect/>
+          </a:stretch>
+        </p:blipFill>
+        <p:spPr>
+          <a:xfrm>
+            <a:off x="2080876" y="0"/>
+            <a:ext cx="8030248" cy="6858000"/>
+          </a:xfrm>
+          <a:prstGeom prst="rect">
+            <a:avLst/>
+          </a:prstGeom>
+        </p:spPr>
+      </p:pic>
+    </p:spTree>
+    <p:extLst>
+      <p:ext uri="{BB962C8B-B14F-4D97-AF65-F5344CB8AC3E}">
+        <p14:creationId xmlns:p14="http://schemas.microsoft.com/office/powerpoint/2010/main" val="1335499219"/>
+      </p:ext>
+    </p:extLst>
+  </p:cSld>
+  <p:clrMapOvr>
+    <a:masterClrMapping/>
+  </p:clrMapOvr>
+</p:sld>
+</file>
+
+<file path=ppt/slides/slide5.xml><?xml version="1.0" encoding="utf-8"?>
 <p:sld xmlns:a="http://schemas.openxmlformats.org/drawingml/2006/main" xmlns:r="http://schemas.openxmlformats.org/officeDocument/2006/relationships" xmlns:p="http://schemas.openxmlformats.org/presentationml/2006/main">
   <p:cSld>
     <p:spTree>
@@ -3558,6 +6050,36 @@
           </a:p>
         </p:txBody>
       </p:sp>
+      <p:pic>
+        <p:nvPicPr>
+          <p:cNvPr id="4" name="Picture 3">
+            <a:extLst>
+              <a:ext uri="{FF2B5EF4-FFF2-40B4-BE49-F238E27FC236}">
+                <a16:creationId xmlns:a16="http://schemas.microsoft.com/office/drawing/2014/main" id="{55AEEC64-659A-A4F5-4B11-CE385FFC2DA7}"/>
+              </a:ext>
+            </a:extLst>
+          </p:cNvPr>
+          <p:cNvPicPr>
+            <a:picLocks noChangeAspect="1"/>
+          </p:cNvPicPr>
+          <p:nvPr/>
+        </p:nvPicPr>
+        <p:blipFill>
+          <a:blip r:embed="rId2"/>
+          <a:stretch>
+            <a:fillRect/>
+          </a:stretch>
+        </p:blipFill>
+        <p:spPr>
+          <a:xfrm>
+            <a:off x="1193703" y="0"/>
+            <a:ext cx="9804593" cy="6858000"/>
+          </a:xfrm>
+          <a:prstGeom prst="rect">
+            <a:avLst/>
+          </a:prstGeom>
+        </p:spPr>
+      </p:pic>
     </p:spTree>
     <p:extLst>
       <p:ext uri="{BB962C8B-B14F-4D97-AF65-F5344CB8AC3E}">
@@ -3571,7 +6093,7 @@
 </p:sld>
 </file>
 
-<file path=ppt/slides/slide4.xml><?xml version="1.0" encoding="utf-8"?>
+<file path=ppt/slides/slide6.xml><?xml version="1.0" encoding="utf-8"?>
 <p:sld xmlns:a="http://schemas.openxmlformats.org/drawingml/2006/main" xmlns:r="http://schemas.openxmlformats.org/officeDocument/2006/relationships" xmlns:p="http://schemas.openxmlformats.org/presentationml/2006/main">
   <p:cSld>
     <p:spTree>
@@ -3644,6 +6166,66 @@
           </a:p>
         </p:txBody>
       </p:sp>
+      <p:pic>
+        <p:nvPicPr>
+          <p:cNvPr id="4" name="Picture 3">
+            <a:extLst>
+              <a:ext uri="{FF2B5EF4-FFF2-40B4-BE49-F238E27FC236}">
+                <a16:creationId xmlns:a16="http://schemas.microsoft.com/office/drawing/2014/main" id="{1475D491-C3E3-856A-B5DB-0D4D54E6A83C}"/>
+              </a:ext>
+            </a:extLst>
+          </p:cNvPr>
+          <p:cNvPicPr>
+            <a:picLocks noChangeAspect="1"/>
+          </p:cNvPicPr>
+          <p:nvPr/>
+        </p:nvPicPr>
+        <p:blipFill>
+          <a:blip r:embed="rId2"/>
+          <a:stretch>
+            <a:fillRect/>
+          </a:stretch>
+        </p:blipFill>
+        <p:spPr>
+          <a:xfrm>
+            <a:off x="0" y="1179588"/>
+            <a:ext cx="12192000" cy="4498823"/>
+          </a:xfrm>
+          <a:prstGeom prst="rect">
+            <a:avLst/>
+          </a:prstGeom>
+          <a:solidFill>
+            <a:srgbClr val="FFFFFF">
+              <a:shade val="85000"/>
+            </a:srgbClr>
+          </a:solidFill>
+          <a:ln w="88900" cap="sq">
+            <a:solidFill>
+              <a:srgbClr val="FFFFFF"/>
+            </a:solidFill>
+            <a:miter lim="800000"/>
+          </a:ln>
+          <a:effectLst>
+            <a:outerShdw blurRad="55000" dist="18000" dir="5400000" algn="tl" rotWithShape="0">
+              <a:srgbClr val="000000">
+                <a:alpha val="40000"/>
+              </a:srgbClr>
+            </a:outerShdw>
+          </a:effectLst>
+          <a:scene3d>
+            <a:camera prst="orthographicFront"/>
+            <a:lightRig rig="twoPt" dir="t">
+              <a:rot lat="0" lon="0" rev="7200000"/>
+            </a:lightRig>
+          </a:scene3d>
+          <a:sp3d>
+            <a:bevelT w="25400" h="19050"/>
+            <a:contourClr>
+              <a:srgbClr val="FFFFFF"/>
+            </a:contourClr>
+          </a:sp3d>
+        </p:spPr>
+      </p:pic>
     </p:spTree>
     <p:extLst>
       <p:ext uri="{BB962C8B-B14F-4D97-AF65-F5344CB8AC3E}">
@@ -3657,7 +6239,7 @@
 </p:sld>
 </file>
 
-<file path=ppt/slides/slide5.xml><?xml version="1.0" encoding="utf-8"?>
+<file path=ppt/slides/slide7.xml><?xml version="1.0" encoding="utf-8"?>
 <p:sld xmlns:a="http://schemas.openxmlformats.org/drawingml/2006/main" xmlns:r="http://schemas.openxmlformats.org/officeDocument/2006/relationships" xmlns:p="http://schemas.openxmlformats.org/presentationml/2006/main">
   <p:cSld>
     <p:spTree>
@@ -3665,7 +6247,7 @@
         <p:cNvPr id="1" name="">
           <a:extLst>
             <a:ext uri="{FF2B5EF4-FFF2-40B4-BE49-F238E27FC236}">
-              <a16:creationId xmlns:a16="http://schemas.microsoft.com/office/drawing/2014/main" id="{234FC578-E916-157D-9E34-98C92603E544}"/>
+              <a16:creationId xmlns:a16="http://schemas.microsoft.com/office/drawing/2014/main" id="{ABCB0769-E157-ED54-98D8-382AE58C22E6}"/>
             </a:ext>
           </a:extLst>
         </p:cNvPr>
@@ -3685,7 +6267,7 @@
           <p:cNvPr id="3" name="TextBox 2">
             <a:extLst>
               <a:ext uri="{FF2B5EF4-FFF2-40B4-BE49-F238E27FC236}">
-                <a16:creationId xmlns:a16="http://schemas.microsoft.com/office/drawing/2014/main" id="{44E910EB-F8CF-72DB-1654-E9E111A3D87E}"/>
+                <a16:creationId xmlns:a16="http://schemas.microsoft.com/office/drawing/2014/main" id="{88ACB9CC-C0D6-D3E2-FC62-EA5F56D624E0}"/>
               </a:ext>
             </a:extLst>
           </p:cNvPr>
@@ -3730,10 +6312,272 @@
           </a:p>
         </p:txBody>
       </p:sp>
+      <p:pic>
+        <p:nvPicPr>
+          <p:cNvPr id="4" name="Picture 3">
+            <a:extLst>
+              <a:ext uri="{FF2B5EF4-FFF2-40B4-BE49-F238E27FC236}">
+                <a16:creationId xmlns:a16="http://schemas.microsoft.com/office/drawing/2014/main" id="{C066F8A9-06F3-C82F-161A-B5EF11573045}"/>
+              </a:ext>
+            </a:extLst>
+          </p:cNvPr>
+          <p:cNvPicPr>
+            <a:picLocks noChangeAspect="1"/>
+          </p:cNvPicPr>
+          <p:nvPr/>
+        </p:nvPicPr>
+        <p:blipFill>
+          <a:blip r:embed="rId2"/>
+          <a:stretch>
+            <a:fillRect/>
+          </a:stretch>
+        </p:blipFill>
+        <p:spPr>
+          <a:xfrm>
+            <a:off x="1070861" y="2514472"/>
+            <a:ext cx="10050278" cy="1829055"/>
+          </a:xfrm>
+          <a:prstGeom prst="rect">
+            <a:avLst/>
+          </a:prstGeom>
+        </p:spPr>
+      </p:pic>
     </p:spTree>
     <p:extLst>
       <p:ext uri="{BB962C8B-B14F-4D97-AF65-F5344CB8AC3E}">
-        <p14:creationId xmlns:p14="http://schemas.microsoft.com/office/powerpoint/2010/main" val="616314994"/>
+        <p14:creationId xmlns:p14="http://schemas.microsoft.com/office/powerpoint/2010/main" val="1412771562"/>
+      </p:ext>
+    </p:extLst>
+  </p:cSld>
+  <p:clrMapOvr>
+    <a:masterClrMapping/>
+  </p:clrMapOvr>
+</p:sld>
+</file>
+
+<file path=ppt/slides/slide8.xml><?xml version="1.0" encoding="utf-8"?>
+<p:sld xmlns:a="http://schemas.openxmlformats.org/drawingml/2006/main" xmlns:r="http://schemas.openxmlformats.org/officeDocument/2006/relationships" xmlns:p="http://schemas.openxmlformats.org/presentationml/2006/main">
+  <p:cSld>
+    <p:spTree>
+      <p:nvGrpSpPr>
+        <p:cNvPr id="1" name="">
+          <a:extLst>
+            <a:ext uri="{FF2B5EF4-FFF2-40B4-BE49-F238E27FC236}">
+              <a16:creationId xmlns:a16="http://schemas.microsoft.com/office/drawing/2014/main" id="{1EEEDFE5-C65F-2314-32E5-AB816F80CBF5}"/>
+            </a:ext>
+          </a:extLst>
+        </p:cNvPr>
+        <p:cNvGrpSpPr/>
+        <p:nvPr/>
+      </p:nvGrpSpPr>
+      <p:grpSpPr>
+        <a:xfrm>
+          <a:off x="0" y="0"/>
+          <a:ext cx="0" cy="0"/>
+          <a:chOff x="0" y="0"/>
+          <a:chExt cx="0" cy="0"/>
+        </a:xfrm>
+      </p:grpSpPr>
+      <p:sp>
+        <p:nvSpPr>
+          <p:cNvPr id="3" name="TextBox 2">
+            <a:extLst>
+              <a:ext uri="{FF2B5EF4-FFF2-40B4-BE49-F238E27FC236}">
+                <a16:creationId xmlns:a16="http://schemas.microsoft.com/office/drawing/2014/main" id="{E90DDAD9-8A1C-ACEA-4431-904C6DD14ACD}"/>
+              </a:ext>
+            </a:extLst>
+          </p:cNvPr>
+          <p:cNvSpPr txBox="1"/>
+          <p:nvPr/>
+        </p:nvSpPr>
+        <p:spPr>
+          <a:xfrm>
+            <a:off x="0" y="0"/>
+            <a:ext cx="12192000" cy="355354"/>
+          </a:xfrm>
+          <a:prstGeom prst="rect">
+            <a:avLst/>
+          </a:prstGeom>
+          <a:noFill/>
+        </p:spPr>
+        <p:txBody>
+          <a:bodyPr wrap="square">
+            <a:spAutoFit/>
+          </a:bodyPr>
+          <a:lstStyle/>
+          <a:p>
+            <a:pPr>
+              <a:lnSpc>
+                <a:spcPct val="150000"/>
+              </a:lnSpc>
+              <a:buNone/>
+            </a:pPr>
+            <a:r>
+              <a:rPr kumimoji="0" lang="en-US" altLang="en-US" sz="1300" b="0" i="0" u="none" strike="noStrike" cap="none" normalizeH="0" baseline="0">
+                <a:ln>
+                  <a:noFill/>
+                </a:ln>
+                <a:solidFill>
+                  <a:schemeClr val="tx1"/>
+                </a:solidFill>
+                <a:effectLst/>
+                <a:latin typeface="Arial" panose="020B0604020202020204" pitchFamily="34" charset="0"/>
+              </a:rPr>
+              <a:t>.</a:t>
+            </a:r>
+          </a:p>
+        </p:txBody>
+      </p:sp>
+      <p:pic>
+        <p:nvPicPr>
+          <p:cNvPr id="4" name="Picture 3">
+            <a:extLst>
+              <a:ext uri="{FF2B5EF4-FFF2-40B4-BE49-F238E27FC236}">
+                <a16:creationId xmlns:a16="http://schemas.microsoft.com/office/drawing/2014/main" id="{A593B9B4-3DD4-D08A-AE59-959869652139}"/>
+              </a:ext>
+            </a:extLst>
+          </p:cNvPr>
+          <p:cNvPicPr>
+            <a:picLocks noChangeAspect="1"/>
+          </p:cNvPicPr>
+          <p:nvPr/>
+        </p:nvPicPr>
+        <p:blipFill>
+          <a:blip r:embed="rId2"/>
+          <a:stretch>
+            <a:fillRect/>
+          </a:stretch>
+        </p:blipFill>
+        <p:spPr>
+          <a:xfrm>
+            <a:off x="1600514" y="0"/>
+            <a:ext cx="8990972" cy="6858000"/>
+          </a:xfrm>
+          <a:prstGeom prst="rect">
+            <a:avLst/>
+          </a:prstGeom>
+        </p:spPr>
+      </p:pic>
+    </p:spTree>
+    <p:extLst>
+      <p:ext uri="{BB962C8B-B14F-4D97-AF65-F5344CB8AC3E}">
+        <p14:creationId xmlns:p14="http://schemas.microsoft.com/office/powerpoint/2010/main" val="30906125"/>
+      </p:ext>
+    </p:extLst>
+  </p:cSld>
+  <p:clrMapOvr>
+    <a:masterClrMapping/>
+  </p:clrMapOvr>
+</p:sld>
+</file>
+
+<file path=ppt/slides/slide9.xml><?xml version="1.0" encoding="utf-8"?>
+<p:sld xmlns:a="http://schemas.openxmlformats.org/drawingml/2006/main" xmlns:r="http://schemas.openxmlformats.org/officeDocument/2006/relationships" xmlns:p="http://schemas.openxmlformats.org/presentationml/2006/main">
+  <p:cSld>
+    <p:spTree>
+      <p:nvGrpSpPr>
+        <p:cNvPr id="1" name="">
+          <a:extLst>
+            <a:ext uri="{FF2B5EF4-FFF2-40B4-BE49-F238E27FC236}">
+              <a16:creationId xmlns:a16="http://schemas.microsoft.com/office/drawing/2014/main" id="{B6BAA9BD-F232-BE99-7817-D9528B5C3A96}"/>
+            </a:ext>
+          </a:extLst>
+        </p:cNvPr>
+        <p:cNvGrpSpPr/>
+        <p:nvPr/>
+      </p:nvGrpSpPr>
+      <p:grpSpPr>
+        <a:xfrm>
+          <a:off x="0" y="0"/>
+          <a:ext cx="0" cy="0"/>
+          <a:chOff x="0" y="0"/>
+          <a:chExt cx="0" cy="0"/>
+        </a:xfrm>
+      </p:grpSpPr>
+      <p:sp>
+        <p:nvSpPr>
+          <p:cNvPr id="3" name="TextBox 2">
+            <a:extLst>
+              <a:ext uri="{FF2B5EF4-FFF2-40B4-BE49-F238E27FC236}">
+                <a16:creationId xmlns:a16="http://schemas.microsoft.com/office/drawing/2014/main" id="{31AD342D-B55D-A600-8870-50C55FCB1944}"/>
+              </a:ext>
+            </a:extLst>
+          </p:cNvPr>
+          <p:cNvSpPr txBox="1"/>
+          <p:nvPr/>
+        </p:nvSpPr>
+        <p:spPr>
+          <a:xfrm>
+            <a:off x="0" y="0"/>
+            <a:ext cx="12192000" cy="355354"/>
+          </a:xfrm>
+          <a:prstGeom prst="rect">
+            <a:avLst/>
+          </a:prstGeom>
+          <a:noFill/>
+        </p:spPr>
+        <p:txBody>
+          <a:bodyPr wrap="square">
+            <a:spAutoFit/>
+          </a:bodyPr>
+          <a:lstStyle/>
+          <a:p>
+            <a:pPr>
+              <a:lnSpc>
+                <a:spcPct val="150000"/>
+              </a:lnSpc>
+              <a:buNone/>
+            </a:pPr>
+            <a:r>
+              <a:rPr kumimoji="0" lang="en-US" altLang="en-US" sz="1300" b="0" i="0" u="none" strike="noStrike" cap="none" normalizeH="0" baseline="0">
+                <a:ln>
+                  <a:noFill/>
+                </a:ln>
+                <a:solidFill>
+                  <a:schemeClr val="tx1"/>
+                </a:solidFill>
+                <a:effectLst/>
+                <a:latin typeface="Arial" panose="020B0604020202020204" pitchFamily="34" charset="0"/>
+              </a:rPr>
+              <a:t>.</a:t>
+            </a:r>
+          </a:p>
+        </p:txBody>
+      </p:sp>
+      <p:pic>
+        <p:nvPicPr>
+          <p:cNvPr id="4" name="Picture 3">
+            <a:extLst>
+              <a:ext uri="{FF2B5EF4-FFF2-40B4-BE49-F238E27FC236}">
+                <a16:creationId xmlns:a16="http://schemas.microsoft.com/office/drawing/2014/main" id="{FD4A6755-8E39-D70B-1D02-F0D831D3D95A}"/>
+              </a:ext>
+            </a:extLst>
+          </p:cNvPr>
+          <p:cNvPicPr>
+            <a:picLocks noChangeAspect="1"/>
+          </p:cNvPicPr>
+          <p:nvPr/>
+        </p:nvPicPr>
+        <p:blipFill>
+          <a:blip r:embed="rId2"/>
+          <a:stretch>
+            <a:fillRect/>
+          </a:stretch>
+        </p:blipFill>
+        <p:spPr>
+          <a:xfrm>
+            <a:off x="2656460" y="0"/>
+            <a:ext cx="6879080" cy="6858000"/>
+          </a:xfrm>
+          <a:prstGeom prst="rect">
+            <a:avLst/>
+          </a:prstGeom>
+        </p:spPr>
+      </p:pic>
+    </p:spTree>
+    <p:extLst>
+      <p:ext uri="{BB962C8B-B14F-4D97-AF65-F5344CB8AC3E}">
+        <p14:creationId xmlns:p14="http://schemas.microsoft.com/office/powerpoint/2010/main" val="2010023699"/>
       </p:ext>
     </p:extLst>
   </p:cSld>

</xml_diff>

<commit_message>
Add To Cart - Show dynamic cart counter
</commit_message>
<xml_diff>
--- a/.lessons/66 Frontend User Multi address/2 User Address- Working with create page/1.pptx
+++ b/.lessons/66 Frontend User Multi address/2 User Address- Working with create page/1.pptx
@@ -285,7 +285,7 @@
           <a:p>
             <a:fld id="{3E102D2E-813C-461C-9963-687A650C48C0}" type="datetimeFigureOut">
               <a:rPr lang="en-US" smtClean="0"/>
-              <a:t>12/31/2025</a:t>
+              <a:t>1/5/2026</a:t>
             </a:fld>
             <a:endParaRPr lang="en-US"/>
           </a:p>
@@ -483,7 +483,7 @@
           <a:p>
             <a:fld id="{3E102D2E-813C-461C-9963-687A650C48C0}" type="datetimeFigureOut">
               <a:rPr lang="en-US" smtClean="0"/>
-              <a:t>12/31/2025</a:t>
+              <a:t>1/5/2026</a:t>
             </a:fld>
             <a:endParaRPr lang="en-US"/>
           </a:p>
@@ -691,7 +691,7 @@
           <a:p>
             <a:fld id="{3E102D2E-813C-461C-9963-687A650C48C0}" type="datetimeFigureOut">
               <a:rPr lang="en-US" smtClean="0"/>
-              <a:t>12/31/2025</a:t>
+              <a:t>1/5/2026</a:t>
             </a:fld>
             <a:endParaRPr lang="en-US"/>
           </a:p>
@@ -889,7 +889,7 @@
           <a:p>
             <a:fld id="{3E102D2E-813C-461C-9963-687A650C48C0}" type="datetimeFigureOut">
               <a:rPr lang="en-US" smtClean="0"/>
-              <a:t>12/31/2025</a:t>
+              <a:t>1/5/2026</a:t>
             </a:fld>
             <a:endParaRPr lang="en-US"/>
           </a:p>
@@ -1164,7 +1164,7 @@
           <a:p>
             <a:fld id="{3E102D2E-813C-461C-9963-687A650C48C0}" type="datetimeFigureOut">
               <a:rPr lang="en-US" smtClean="0"/>
-              <a:t>12/31/2025</a:t>
+              <a:t>1/5/2026</a:t>
             </a:fld>
             <a:endParaRPr lang="en-US"/>
           </a:p>
@@ -1429,7 +1429,7 @@
           <a:p>
             <a:fld id="{3E102D2E-813C-461C-9963-687A650C48C0}" type="datetimeFigureOut">
               <a:rPr lang="en-US" smtClean="0"/>
-              <a:t>12/31/2025</a:t>
+              <a:t>1/5/2026</a:t>
             </a:fld>
             <a:endParaRPr lang="en-US"/>
           </a:p>
@@ -1841,7 +1841,7 @@
           <a:p>
             <a:fld id="{3E102D2E-813C-461C-9963-687A650C48C0}" type="datetimeFigureOut">
               <a:rPr lang="en-US" smtClean="0"/>
-              <a:t>12/31/2025</a:t>
+              <a:t>1/5/2026</a:t>
             </a:fld>
             <a:endParaRPr lang="en-US"/>
           </a:p>
@@ -1982,7 +1982,7 @@
           <a:p>
             <a:fld id="{3E102D2E-813C-461C-9963-687A650C48C0}" type="datetimeFigureOut">
               <a:rPr lang="en-US" smtClean="0"/>
-              <a:t>12/31/2025</a:t>
+              <a:t>1/5/2026</a:t>
             </a:fld>
             <a:endParaRPr lang="en-US"/>
           </a:p>
@@ -2095,7 +2095,7 @@
           <a:p>
             <a:fld id="{3E102D2E-813C-461C-9963-687A650C48C0}" type="datetimeFigureOut">
               <a:rPr lang="en-US" smtClean="0"/>
-              <a:t>12/31/2025</a:t>
+              <a:t>1/5/2026</a:t>
             </a:fld>
             <a:endParaRPr lang="en-US"/>
           </a:p>
@@ -2406,7 +2406,7 @@
           <a:p>
             <a:fld id="{3E102D2E-813C-461C-9963-687A650C48C0}" type="datetimeFigureOut">
               <a:rPr lang="en-US" smtClean="0"/>
-              <a:t>12/31/2025</a:t>
+              <a:t>1/5/2026</a:t>
             </a:fld>
             <a:endParaRPr lang="en-US"/>
           </a:p>
@@ -2694,7 +2694,7 @@
           <a:p>
             <a:fld id="{3E102D2E-813C-461C-9963-687A650C48C0}" type="datetimeFigureOut">
               <a:rPr lang="en-US" smtClean="0"/>
-              <a:t>12/31/2025</a:t>
+              <a:t>1/5/2026</a:t>
             </a:fld>
             <a:endParaRPr lang="en-US"/>
           </a:p>
@@ -2935,7 +2935,7 @@
           <a:p>
             <a:fld id="{3E102D2E-813C-461C-9963-687A650C48C0}" type="datetimeFigureOut">
               <a:rPr lang="en-US" smtClean="0"/>
-              <a:t>12/31/2025</a:t>
+              <a:t>1/5/2026</a:t>
             </a:fld>
             <a:endParaRPr lang="en-US"/>
           </a:p>
@@ -3438,36 +3438,6 @@
           </a:prstGeom>
         </p:spPr>
       </p:pic>
-      <p:pic>
-        <p:nvPicPr>
-          <p:cNvPr id="5" name="Picture 4">
-            <a:extLst>
-              <a:ext uri="{FF2B5EF4-FFF2-40B4-BE49-F238E27FC236}">
-                <a16:creationId xmlns:a16="http://schemas.microsoft.com/office/drawing/2014/main" id="{84E730A5-C5F7-A624-46A2-1CA13CF498B5}"/>
-              </a:ext>
-            </a:extLst>
-          </p:cNvPr>
-          <p:cNvPicPr>
-            <a:picLocks noChangeAspect="1"/>
-          </p:cNvPicPr>
-          <p:nvPr/>
-        </p:nvPicPr>
-        <p:blipFill>
-          <a:blip r:embed="rId2"/>
-          <a:stretch>
-            <a:fillRect/>
-          </a:stretch>
-        </p:blipFill>
-        <p:spPr>
-          <a:xfrm>
-            <a:off x="3286357" y="152400"/>
-            <a:ext cx="5924085" cy="6858000"/>
-          </a:xfrm>
-          <a:prstGeom prst="rect">
-            <a:avLst/>
-          </a:prstGeom>
-        </p:spPr>
-      </p:pic>
     </p:spTree>
     <p:extLst>
       <p:ext uri="{BB962C8B-B14F-4D97-AF65-F5344CB8AC3E}">

</xml_diff>